<commit_message>
fix: preserva estrutura original do modelo CTT nas apresentações
Restaura capa, abertura de seção, sumário e encerramento, mantendo os dados compactos e os espaços de rastro selecionados. Adapta a pauta à análise e preserva os slides estruturais mesmo sem retornos ou rastros.

Atualiza o modelo editável, a documentação e os testes de ordem, conteúdo e preservação das imagens originais nas quatro unidades. Validação: 73 testes Python e quatro suítes JavaScript aprovados.
</commit_message>
<xml_diff>
--- a/templates/presentations/ctt_compact_template.pptx
+++ b/templates/presentations/ctt_compact_template.pptx
@@ -2,23 +2,23 @@
 <file path=ppt/presentation.xml><?xml version="1.0" encoding="utf-8"?>
 <p:presentation xmlns:p="http://schemas.openxmlformats.org/presentationml/2006/main">
   <p:sldMasterIdLst>
-    <p:sldMasterId xmlns:r="http://schemas.openxmlformats.org/officeDocument/2006/relationships" id="2147483648" r:id="R7a9d8f71c32b4ad3"/>
+    <p:sldMasterId xmlns:r="http://schemas.openxmlformats.org/officeDocument/2006/relationships" id="2147483648" r:id="Re024c75017784faf"/>
   </p:sldMasterIdLst>
   <p:notesMasterIdLst>
-    <p:notesMasterId xmlns:r="http://schemas.openxmlformats.org/officeDocument/2006/relationships" r:id="Rdc77d76637ce4423"/>
+    <p:notesMasterId xmlns:r="http://schemas.openxmlformats.org/officeDocument/2006/relationships" r:id="R078f695a409d44c7"/>
   </p:notesMasterIdLst>
   <p:sldIdLst>
-    <p:sldId xmlns:r="http://schemas.openxmlformats.org/officeDocument/2006/relationships" id="256" r:id="R97f22266a6ae4d1e"/>
-    <p:sldId xmlns:r="http://schemas.openxmlformats.org/officeDocument/2006/relationships" id="257" r:id="R8d5a635180904e03"/>
-    <p:sldId xmlns:r="http://schemas.openxmlformats.org/officeDocument/2006/relationships" id="258" r:id="R13c3b601a4214fa1"/>
-    <p:sldId xmlns:r="http://schemas.openxmlformats.org/officeDocument/2006/relationships" id="259" r:id="R74d8908c731549cd"/>
-    <p:sldId xmlns:r="http://schemas.openxmlformats.org/officeDocument/2006/relationships" id="260" r:id="R9a7b99520313480a"/>
-    <p:sldId xmlns:r="http://schemas.openxmlformats.org/officeDocument/2006/relationships" id="261" r:id="R50d53f68578b4a60"/>
-    <p:sldId xmlns:r="http://schemas.openxmlformats.org/officeDocument/2006/relationships" id="262" r:id="Rf3f91d4db37546a6"/>
-    <p:sldId xmlns:r="http://schemas.openxmlformats.org/officeDocument/2006/relationships" id="263" r:id="R80e2b9f6e7494266"/>
-    <p:sldId xmlns:r="http://schemas.openxmlformats.org/officeDocument/2006/relationships" id="264" r:id="Rf1fa43bff2484a80"/>
-    <p:sldId xmlns:r="http://schemas.openxmlformats.org/officeDocument/2006/relationships" id="265" r:id="Rff1181f505b643a3"/>
-    <p:sldId xmlns:r="http://schemas.openxmlformats.org/officeDocument/2006/relationships" id="266" r:id="Re8fb963563474729"/>
+    <p:sldId xmlns:r="http://schemas.openxmlformats.org/officeDocument/2006/relationships" id="256" r:id="Rbfd00a9750e14619"/>
+    <p:sldId xmlns:r="http://schemas.openxmlformats.org/officeDocument/2006/relationships" id="257" r:id="Rc24d623e08ae475f"/>
+    <p:sldId xmlns:r="http://schemas.openxmlformats.org/officeDocument/2006/relationships" id="258" r:id="R89f83401bb3a4493"/>
+    <p:sldId xmlns:r="http://schemas.openxmlformats.org/officeDocument/2006/relationships" id="259" r:id="Rad9ba72c7cbe4743"/>
+    <p:sldId xmlns:r="http://schemas.openxmlformats.org/officeDocument/2006/relationships" id="260" r:id="R6bd4e5c7533e4419"/>
+    <p:sldId xmlns:r="http://schemas.openxmlformats.org/officeDocument/2006/relationships" id="261" r:id="Rb215d53d9f1c4910"/>
+    <p:sldId xmlns:r="http://schemas.openxmlformats.org/officeDocument/2006/relationships" id="262" r:id="R8f924f6b834848db"/>
+    <p:sldId xmlns:r="http://schemas.openxmlformats.org/officeDocument/2006/relationships" id="263" r:id="R124b2440d4a84139"/>
+    <p:sldId xmlns:r="http://schemas.openxmlformats.org/officeDocument/2006/relationships" id="264" r:id="R266d8fc5909a4b0d"/>
+    <p:sldId xmlns:r="http://schemas.openxmlformats.org/officeDocument/2006/relationships" id="265" r:id="R01049cdd97324794"/>
+    <p:sldId xmlns:r="http://schemas.openxmlformats.org/officeDocument/2006/relationships" id="266" r:id="Ra7410013a3fd4a7d"/>
   </p:sldIdLst>
   <p:sldSz cx="12192000" cy="6858000"/>
   <p:notesSz cx="6858000" cy="9144000"/>
@@ -577,7 +577,11 @@
         <p:txBody>
           <a:bodyPr xmlns:a="http://schemas.openxmlformats.org/drawingml/2006/main"/>
           <a:lstStyle xmlns:a="http://schemas.openxmlformats.org/drawingml/2006/main"/>
-          <a:p xmlns:a="http://schemas.openxmlformats.org/drawingml/2006/main"/>
+          <a:p xmlns:a="http://schemas.openxmlformats.org/drawingml/2006/main">
+            <a:r>
+              <a:t>{{notes}}</a:t>
+            </a:r>
+          </a:p>
         </p:txBody>
       </p:sp>
       <p:sp>
@@ -643,7 +647,11 @@
         <p:txBody>
           <a:bodyPr xmlns:a="http://schemas.openxmlformats.org/drawingml/2006/main"/>
           <a:lstStyle xmlns:a="http://schemas.openxmlformats.org/drawingml/2006/main"/>
-          <a:p xmlns:a="http://schemas.openxmlformats.org/drawingml/2006/main"/>
+          <a:p xmlns:a="http://schemas.openxmlformats.org/drawingml/2006/main">
+            <a:r>
+              <a:t>{{notes}}</a:t>
+            </a:r>
+          </a:p>
         </p:txBody>
       </p:sp>
       <p:sp>
@@ -779,7 +787,11 @@
         <p:txBody>
           <a:bodyPr xmlns:a="http://schemas.openxmlformats.org/drawingml/2006/main"/>
           <a:lstStyle xmlns:a="http://schemas.openxmlformats.org/drawingml/2006/main"/>
-          <a:p xmlns:a="http://schemas.openxmlformats.org/drawingml/2006/main"/>
+          <a:p xmlns:a="http://schemas.openxmlformats.org/drawingml/2006/main">
+            <a:r>
+              <a:t>{{notes}}</a:t>
+            </a:r>
+          </a:p>
         </p:txBody>
       </p:sp>
       <p:sp>
@@ -845,7 +857,11 @@
         <p:txBody>
           <a:bodyPr xmlns:a="http://schemas.openxmlformats.org/drawingml/2006/main"/>
           <a:lstStyle xmlns:a="http://schemas.openxmlformats.org/drawingml/2006/main"/>
-          <a:p xmlns:a="http://schemas.openxmlformats.org/drawingml/2006/main"/>
+          <a:p xmlns:a="http://schemas.openxmlformats.org/drawingml/2006/main">
+            <a:r>
+              <a:t>{{notes}}</a:t>
+            </a:r>
+          </a:p>
         </p:txBody>
       </p:sp>
       <p:sp>
@@ -4257,17 +4273,17 @@
   </p:cSld>
   <p:clrMap bg1="lt1" tx1="dk1" bg2="lt2" tx2="dk2" accent1="accent1" accent2="accent2" accent3="accent3" accent4="accent4" accent5="accent5" accent6="accent6" hlink="hlink" folHlink="folHlink"/>
   <p:sldLayoutIdLst>
-    <p:sldLayoutId xmlns:r="http://schemas.openxmlformats.org/officeDocument/2006/relationships" id="2147483649" r:id="Rd1b58635511b4fcb"/>
-    <p:sldLayoutId xmlns:r="http://schemas.openxmlformats.org/officeDocument/2006/relationships" id="2147483650" r:id="R7c6ef8ce96254b92"/>
-    <p:sldLayoutId xmlns:r="http://schemas.openxmlformats.org/officeDocument/2006/relationships" id="2147483651" r:id="R9742898abffa4039"/>
-    <p:sldLayoutId xmlns:r="http://schemas.openxmlformats.org/officeDocument/2006/relationships" id="2147483652" r:id="R051d90faeb80441a"/>
-    <p:sldLayoutId xmlns:r="http://schemas.openxmlformats.org/officeDocument/2006/relationships" id="2147483653" r:id="Rcba76ea0587842fd"/>
-    <p:sldLayoutId xmlns:r="http://schemas.openxmlformats.org/officeDocument/2006/relationships" id="2147483654" r:id="Rcf55a6cd1b34447f"/>
-    <p:sldLayoutId xmlns:r="http://schemas.openxmlformats.org/officeDocument/2006/relationships" id="2147483655" r:id="R59d9d6f9d3ce4b61"/>
-    <p:sldLayoutId xmlns:r="http://schemas.openxmlformats.org/officeDocument/2006/relationships" id="2147483656" r:id="R17fe0ae22d8d4349"/>
-    <p:sldLayoutId xmlns:r="http://schemas.openxmlformats.org/officeDocument/2006/relationships" id="2147483657" r:id="R7730cd9e61454b06"/>
-    <p:sldLayoutId xmlns:r="http://schemas.openxmlformats.org/officeDocument/2006/relationships" id="2147483658" r:id="Rff7145c6c4cb42c2"/>
-    <p:sldLayoutId xmlns:r="http://schemas.openxmlformats.org/officeDocument/2006/relationships" id="2147483659" r:id="Rb2ac38632d3143b7"/>
+    <p:sldLayoutId xmlns:r="http://schemas.openxmlformats.org/officeDocument/2006/relationships" id="2147483649" r:id="R3bee3e0d8a1d4f79"/>
+    <p:sldLayoutId xmlns:r="http://schemas.openxmlformats.org/officeDocument/2006/relationships" id="2147483650" r:id="R35d6cf992ba04891"/>
+    <p:sldLayoutId xmlns:r="http://schemas.openxmlformats.org/officeDocument/2006/relationships" id="2147483651" r:id="Ra3d06c17d3ab471a"/>
+    <p:sldLayoutId xmlns:r="http://schemas.openxmlformats.org/officeDocument/2006/relationships" id="2147483652" r:id="R2ce995e890b44b20"/>
+    <p:sldLayoutId xmlns:r="http://schemas.openxmlformats.org/officeDocument/2006/relationships" id="2147483653" r:id="R63c336c5e9914022"/>
+    <p:sldLayoutId xmlns:r="http://schemas.openxmlformats.org/officeDocument/2006/relationships" id="2147483654" r:id="R35cef4fdfc204c25"/>
+    <p:sldLayoutId xmlns:r="http://schemas.openxmlformats.org/officeDocument/2006/relationships" id="2147483655" r:id="R84590e3f05954f77"/>
+    <p:sldLayoutId xmlns:r="http://schemas.openxmlformats.org/officeDocument/2006/relationships" id="2147483656" r:id="R406860f5603c440f"/>
+    <p:sldLayoutId xmlns:r="http://schemas.openxmlformats.org/officeDocument/2006/relationships" id="2147483657" r:id="R943f0724fad14e73"/>
+    <p:sldLayoutId xmlns:r="http://schemas.openxmlformats.org/officeDocument/2006/relationships" id="2147483658" r:id="Rdecd5da36b4f4311"/>
+    <p:sldLayoutId xmlns:r="http://schemas.openxmlformats.org/officeDocument/2006/relationships" id="2147483659" r:id="R3aeb2412c7254e65"/>
   </p:sldLayoutIdLst>
   <p:txStyles>
     <p:titleStyle>
@@ -4817,7 +4833,7 @@
           <p:nvPr/>
         </p:nvPicPr>
         <p:blipFill>
-          <a:blip xmlns:r="http://schemas.openxmlformats.org/officeDocument/2006/relationships" xmlns:a="http://schemas.openxmlformats.org/drawingml/2006/main" r:embed="R0875aed245d94fee"/>
+          <a:blip xmlns:r="http://schemas.openxmlformats.org/officeDocument/2006/relationships" xmlns:a="http://schemas.openxmlformats.org/drawingml/2006/main" r:embed="R6c3ea812fefc4026"/>
           <a:stretch xmlns:a="http://schemas.openxmlformats.org/drawingml/2006/main">
             <a:fillRect l="0" t="0" r="0" b="0"/>
           </a:stretch>
@@ -5193,7 +5209,7 @@
           <p:nvPr/>
         </p:nvPicPr>
         <p:blipFill>
-          <a:blip xmlns:r="http://schemas.openxmlformats.org/officeDocument/2006/relationships" xmlns:a="http://schemas.openxmlformats.org/drawingml/2006/main" r:embed="Rb001c55b8fa54e0c"/>
+          <a:blip xmlns:r="http://schemas.openxmlformats.org/officeDocument/2006/relationships" xmlns:a="http://schemas.openxmlformats.org/drawingml/2006/main" r:embed="R3b3b0000ab134f44"/>
           <a:stretch xmlns:a="http://schemas.openxmlformats.org/drawingml/2006/main">
             <a:fillRect l="0" t="0" r="0" b="0"/>
           </a:stretch>
@@ -5250,7 +5266,7 @@
                 <a:ea typeface="Calibri Light"/>
                 <a:cs typeface="Calibri Light"/>
               </a:rPr>
-              <a:t>Análise de mudanças de área</a:t>
+              <a:t>{{closing_title}}</a:t>
             </a:r>
           </a:p>
         </p:txBody>
@@ -5326,14 +5342,14 @@
       </p:grpSpPr>
       <p:pic>
         <p:nvPicPr>
-          <p:cNvPr id="31" name="Picture 1"/>
+          <p:cNvPr id="32" name="Picture 1"/>
           <p:cNvPicPr>
             <a:picLocks xmlns:a="http://schemas.openxmlformats.org/drawingml/2006/main" noChangeAspect="1"/>
           </p:cNvPicPr>
           <p:nvPr/>
         </p:nvPicPr>
         <p:blipFill>
-          <a:blip xmlns:r="http://schemas.openxmlformats.org/officeDocument/2006/relationships" xmlns:a="http://schemas.openxmlformats.org/drawingml/2006/main" r:embed="R2f141fb97bde4621"/>
+          <a:blip xmlns:r="http://schemas.openxmlformats.org/officeDocument/2006/relationships" xmlns:a="http://schemas.openxmlformats.org/drawingml/2006/main" r:embed="R1a1ed922cf914549"/>
           <a:stretch xmlns:a="http://schemas.openxmlformats.org/drawingml/2006/main">
             <a:fillRect l="0" t="0" r="0" b="0"/>
           </a:stretch>
@@ -5661,6 +5677,7 @@
           <a:lstStyle xmlns:a="http://schemas.openxmlformats.org/drawingml/2006/main"/>
           <a:p xmlns:a="http://schemas.openxmlformats.org/drawingml/2006/main">
             <a:pPr>
+              <a:buNone/>
               <a:defRPr sz="1800">
                 <a:solidFill>
                   <a:srgbClr val="30515F"/>
@@ -5713,6 +5730,7 @@
           <a:lstStyle xmlns:a="http://schemas.openxmlformats.org/drawingml/2006/main"/>
           <a:p xmlns:a="http://schemas.openxmlformats.org/drawingml/2006/main">
             <a:pPr algn="ctr">
+              <a:buNone/>
               <a:defRPr sz="2100">
                 <a:solidFill>
                   <a:srgbClr val="7F7F7F"/>
@@ -5770,6 +5788,7 @@
           <a:lstStyle xmlns:a="http://schemas.openxmlformats.org/drawingml/2006/main"/>
           <a:p xmlns:a="http://schemas.openxmlformats.org/drawingml/2006/main">
             <a:pPr>
+              <a:buNone/>
               <a:defRPr sz="1350">
                 <a:solidFill>
                   <a:srgbClr val="30515F"/>
@@ -5824,7 +5843,7 @@
           <p:nvPr/>
         </p:nvPicPr>
         <p:blipFill>
-          <a:blip xmlns:r="http://schemas.openxmlformats.org/officeDocument/2006/relationships" xmlns:a="http://schemas.openxmlformats.org/drawingml/2006/main" r:embed="Rba98efafc8ed4e8c"/>
+          <a:blip xmlns:r="http://schemas.openxmlformats.org/officeDocument/2006/relationships" xmlns:a="http://schemas.openxmlformats.org/drawingml/2006/main" r:embed="R9ce0c25d85ff4f4d"/>
           <a:stretch xmlns:a="http://schemas.openxmlformats.org/drawingml/2006/main">
             <a:fillRect l="0" t="0" r="0" b="0"/>
           </a:stretch>
@@ -5841,7 +5860,7 @@
       </p:pic>
       <p:sp>
         <p:nvSpPr>
-          <p:cNvPr id="3" name="TextBox 2">
+          <p:cNvPr id="3" name="ctt:section_label">
             <a:extLst xmlns:a="http://schemas.openxmlformats.org/drawingml/2006/main">
               <a:ext uri="{FF2B5EF4-FFF2-40B4-BE49-F238E27FC236}">
                 <a16:creationId xmlns:a16="http://schemas.microsoft.com/office/drawing/2014/main" id="{FC700AB7-E504-4BA2-B1BA-FEF00F936764}"/>
@@ -5881,14 +5900,14 @@
                 <a:ea typeface="Calibri"/>
                 <a:cs typeface="Calibri"/>
               </a:rPr>
-              <a:t>NOME DA SEÇÃO</a:t>
-            </a:r>
-          </a:p>
-        </p:txBody>
-      </p:sp>
-      <p:sp>
-        <p:nvSpPr>
-          <p:cNvPr id="4" name="TextBox 3">
+              <a:t>{{section_label}}</a:t>
+            </a:r>
+          </a:p>
+        </p:txBody>
+      </p:sp>
+      <p:sp>
+        <p:nvSpPr>
+          <p:cNvPr id="4" name="ctt:section_title">
             <a:extLst xmlns:a="http://schemas.openxmlformats.org/drawingml/2006/main">
               <a:ext uri="{FF2B5EF4-FFF2-40B4-BE49-F238E27FC236}">
                 <a16:creationId xmlns:a16="http://schemas.microsoft.com/office/drawing/2014/main" id="{0FF14364-299D-44DE-9598-4EAC51F0F0F0}"/>
@@ -5928,14 +5947,14 @@
                 <a:ea typeface="Calibri Light"/>
                 <a:cs typeface="Calibri Light"/>
               </a:rPr>
-              <a:t>Título da seção</a:t>
-            </a:r>
-          </a:p>
-        </p:txBody>
-      </p:sp>
-      <p:sp>
-        <p:nvSpPr>
-          <p:cNvPr id="5" name="TextBox 4">
+              <a:t>{{section_title}}</a:t>
+            </a:r>
+          </a:p>
+        </p:txBody>
+      </p:sp>
+      <p:sp>
+        <p:nvSpPr>
+          <p:cNvPr id="5" name="ctt:section_scope">
             <a:extLst xmlns:a="http://schemas.openxmlformats.org/drawingml/2006/main">
               <a:ext uri="{FF2B5EF4-FFF2-40B4-BE49-F238E27FC236}">
                 <a16:creationId xmlns:a16="http://schemas.microsoft.com/office/drawing/2014/main" id="{7F106F25-0463-47A6-97CE-F1350E47ECFA}"/>
@@ -5975,7 +5994,7 @@
                 <a:ea typeface="Calibri"/>
                 <a:cs typeface="Calibri"/>
               </a:rPr>
-              <a:t>Subtítulo / tema</a:t>
+              <a:t>{{section_scope}}</a:t>
             </a:r>
             <a:endParaRPr sz="1850" b="0">
               <a:solidFill>
@@ -6093,7 +6112,7 @@
       </p:sp>
       <p:sp>
         <p:nvSpPr>
-          <p:cNvPr id="8" name="TextBox 7">
+          <p:cNvPr id="8" name="ctt:section_caption">
             <a:extLst xmlns:a="http://schemas.openxmlformats.org/drawingml/2006/main">
               <a:ext uri="{FF2B5EF4-FFF2-40B4-BE49-F238E27FC236}">
                 <a16:creationId xmlns:a16="http://schemas.microsoft.com/office/drawing/2014/main" id="{2B940987-35D0-43E9-81E1-849287FEAD1B}"/>
@@ -6133,7 +6152,7 @@
                 <a:ea typeface="Calibri"/>
                 <a:cs typeface="Calibri"/>
               </a:rPr>
-              <a:t>Descrição breve</a:t>
+              <a:t>{{section_caption}}</a:t>
             </a:r>
           </a:p>
         </p:txBody>
@@ -6169,7 +6188,7 @@
           <p:nvPr/>
         </p:nvPicPr>
         <p:blipFill>
-          <a:blip xmlns:r="http://schemas.openxmlformats.org/officeDocument/2006/relationships" xmlns:a="http://schemas.openxmlformats.org/drawingml/2006/main" r:embed="R06e3303a78f849d8"/>
+          <a:blip xmlns:r="http://schemas.openxmlformats.org/officeDocument/2006/relationships" xmlns:a="http://schemas.openxmlformats.org/drawingml/2006/main" r:embed="Red4686f917e645ea"/>
           <a:stretch xmlns:a="http://schemas.openxmlformats.org/drawingml/2006/main">
             <a:fillRect l="0" t="0" r="0" b="0"/>
           </a:stretch>
@@ -6186,7 +6205,7 @@
       </p:pic>
       <p:sp>
         <p:nvSpPr>
-          <p:cNvPr id="3" name="TextBox 2">
+          <p:cNvPr id="3" name="ctt:agenda_title">
             <a:extLst xmlns:a="http://schemas.openxmlformats.org/drawingml/2006/main">
               <a:ext uri="{FF2B5EF4-FFF2-40B4-BE49-F238E27FC236}">
                 <a16:creationId xmlns:a16="http://schemas.microsoft.com/office/drawing/2014/main" id="{16585C29-CC64-47FD-A228-21B2A9484B37}"/>
@@ -6201,7 +6220,7 @@
         <p:spPr>
           <a:xfrm xmlns:a="http://schemas.openxmlformats.org/drawingml/2006/main">
             <a:off x="566928" y="411480"/>
-            <a:ext cx="3200400" cy="502920"/>
+            <a:ext cx="10477500" cy="502920"/>
           </a:xfrm>
           <a:prstGeom xmlns:a="http://schemas.openxmlformats.org/drawingml/2006/main" prst="rect">
             <a:avLst/>
@@ -6226,14 +6245,14 @@
                 <a:ea typeface="Calibri Light"/>
                 <a:cs typeface="Calibri Light"/>
               </a:rPr>
-              <a:t>SUMÁRIO</a:t>
-            </a:r>
-          </a:p>
-        </p:txBody>
-      </p:sp>
-      <p:sp>
-        <p:nvSpPr>
-          <p:cNvPr id="4" name="TextBox 3">
+              <a:t>{{agenda_title}}</a:t>
+            </a:r>
+          </a:p>
+        </p:txBody>
+      </p:sp>
+      <p:sp>
+        <p:nvSpPr>
+          <p:cNvPr id="4" name="ctt:agenda_scope">
             <a:extLst xmlns:a="http://schemas.openxmlformats.org/drawingml/2006/main">
               <a:ext uri="{FF2B5EF4-FFF2-40B4-BE49-F238E27FC236}">
                 <a16:creationId xmlns:a16="http://schemas.microsoft.com/office/drawing/2014/main" id="{55C48F12-E0B2-48DC-8A43-FB9E17585510}"/>
@@ -6248,7 +6267,7 @@
         <p:spPr>
           <a:xfrm xmlns:a="http://schemas.openxmlformats.org/drawingml/2006/main">
             <a:off x="585216" y="896112"/>
-            <a:ext cx="4754880" cy="292608"/>
+            <a:ext cx="10477500" cy="292608"/>
           </a:xfrm>
           <a:prstGeom xmlns:a="http://schemas.openxmlformats.org/drawingml/2006/main" prst="rect">
             <a:avLst/>
@@ -6273,7 +6292,7 @@
                 <a:ea typeface="Calibri"/>
                 <a:cs typeface="Calibri"/>
               </a:rPr>
-              <a:t>Descrição breve da apresentação</a:t>
+              <a:t>{{agenda_scope}}</a:t>
             </a:r>
           </a:p>
         </p:txBody>
@@ -6439,7 +6458,7 @@
       </p:sp>
       <p:sp>
         <p:nvSpPr>
-          <p:cNvPr id="8" name="TextBox 7">
+          <p:cNvPr id="8" name="ctt:agenda_item1">
             <a:extLst xmlns:a="http://schemas.openxmlformats.org/drawingml/2006/main">
               <a:ext uri="{FF2B5EF4-FFF2-40B4-BE49-F238E27FC236}">
                 <a16:creationId xmlns:a16="http://schemas.microsoft.com/office/drawing/2014/main" id="{56B5658F-6941-4040-876E-60E3BAAB8216}"/>
@@ -6453,8 +6472,8 @@
         </p:nvSpPr>
         <p:spPr>
           <a:xfrm xmlns:a="http://schemas.openxmlformats.org/drawingml/2006/main">
-            <a:off x="1335024" y="1824238"/>
-            <a:ext cx="65" cy="155427"/>
+            <a:off x="1335024" y="1657350"/>
+            <a:ext cx="4238625" cy="495300"/>
           </a:xfrm>
           <a:prstGeom xmlns:a="http://schemas.openxmlformats.org/drawingml/2006/main" prst="rect">
             <a:avLst/>
@@ -6463,10 +6482,31 @@
         </p:spPr>
         <p:txBody>
           <a:bodyPr xmlns:a="http://schemas.openxmlformats.org/drawingml/2006/main" wrap="none" lIns="0" tIns="0" rIns="0" bIns="0" anchor="ctr">
-            <a:spAutoFit/>
+            <a:noAutofit/>
           </a:bodyPr>
           <a:lstStyle xmlns:a="http://schemas.openxmlformats.org/drawingml/2006/main"/>
           <a:p xmlns:a="http://schemas.openxmlformats.org/drawingml/2006/main">
+            <a:pPr>
+              <a:defRPr sz="1800">
+                <a:solidFill>
+                  <a:srgbClr val="FFFFFF"/>
+                </a:solidFill>
+                <a:latin typeface="Calibri"/>
+                <a:ea typeface="Calibri"/>
+                <a:cs typeface="Calibri"/>
+              </a:defRPr>
+            </a:pPr>
+            <a:r>
+              <a:rPr sz="1800">
+                <a:solidFill>
+                  <a:srgbClr val="FFFFFF"/>
+                </a:solidFill>
+                <a:latin typeface="Calibri"/>
+                <a:ea typeface="Calibri"/>
+                <a:cs typeface="Calibri"/>
+              </a:rPr>
+              <a:t>{{agenda_item1}}</a:t>
+            </a:r>
             <a:endParaRPr sz="1010" b="1">
               <a:solidFill>
                 <a:srgbClr val="FFFFFF"/>
@@ -6636,7 +6676,7 @@
       </p:sp>
       <p:sp>
         <p:nvSpPr>
-          <p:cNvPr id="12" name="TextBox 11">
+          <p:cNvPr id="12" name="ctt:agenda_item2">
             <a:extLst xmlns:a="http://schemas.openxmlformats.org/drawingml/2006/main">
               <a:ext uri="{FF2B5EF4-FFF2-40B4-BE49-F238E27FC236}">
                 <a16:creationId xmlns:a16="http://schemas.microsoft.com/office/drawing/2014/main" id="{55CC8FB9-099F-4AE2-BCFF-EDC8F81CEC3A}"/>
@@ -6650,8 +6690,8 @@
         </p:nvSpPr>
         <p:spPr>
           <a:xfrm xmlns:a="http://schemas.openxmlformats.org/drawingml/2006/main">
-            <a:off x="6986016" y="1813738"/>
-            <a:ext cx="65" cy="155427"/>
+            <a:off x="6986016" y="1657350"/>
+            <a:ext cx="4238625" cy="495300"/>
           </a:xfrm>
           <a:prstGeom xmlns:a="http://schemas.openxmlformats.org/drawingml/2006/main" prst="rect">
             <a:avLst/>
@@ -6660,13 +6700,32 @@
         </p:spPr>
         <p:txBody>
           <a:bodyPr xmlns:a="http://schemas.openxmlformats.org/drawingml/2006/main" wrap="none" lIns="0" tIns="0" rIns="0" bIns="0" anchor="ctr">
-            <a:spAutoFit/>
+            <a:noAutofit/>
           </a:bodyPr>
           <a:lstStyle xmlns:a="http://schemas.openxmlformats.org/drawingml/2006/main"/>
           <a:p xmlns:a="http://schemas.openxmlformats.org/drawingml/2006/main">
             <a:pPr algn="l">
               <a:buNone/>
-            </a:pPr>
+              <a:defRPr sz="1800">
+                <a:solidFill>
+                  <a:srgbClr val="FFFFFF"/>
+                </a:solidFill>
+                <a:latin typeface="Calibri"/>
+                <a:ea typeface="Calibri"/>
+                <a:cs typeface="Calibri"/>
+              </a:defRPr>
+            </a:pPr>
+            <a:r>
+              <a:rPr sz="1800">
+                <a:solidFill>
+                  <a:srgbClr val="FFFFFF"/>
+                </a:solidFill>
+                <a:latin typeface="Calibri"/>
+                <a:ea typeface="Calibri"/>
+                <a:cs typeface="Calibri"/>
+              </a:rPr>
+              <a:t>{{agenda_item2}}</a:t>
+            </a:r>
             <a:endParaRPr sz="1010" b="1">
               <a:solidFill>
                 <a:srgbClr val="FFFFFF"/>
@@ -6839,7 +6898,7 @@
       </p:sp>
       <p:sp>
         <p:nvSpPr>
-          <p:cNvPr id="16" name="TextBox 15">
+          <p:cNvPr id="16" name="ctt:agenda_item3">
             <a:extLst xmlns:a="http://schemas.openxmlformats.org/drawingml/2006/main">
               <a:ext uri="{FF2B5EF4-FFF2-40B4-BE49-F238E27FC236}">
                 <a16:creationId xmlns:a16="http://schemas.microsoft.com/office/drawing/2014/main" id="{3806A829-C22C-45BF-BF4D-AA7DE75FBB9A}"/>
@@ -6853,8 +6912,8 @@
         </p:nvSpPr>
         <p:spPr>
           <a:xfrm xmlns:a="http://schemas.openxmlformats.org/drawingml/2006/main">
-            <a:off x="1335024" y="3012958"/>
-            <a:ext cx="65" cy="155427"/>
+            <a:off x="1335024" y="2847975"/>
+            <a:ext cx="4238625" cy="495300"/>
           </a:xfrm>
           <a:prstGeom xmlns:a="http://schemas.openxmlformats.org/drawingml/2006/main" prst="rect">
             <a:avLst/>
@@ -6863,13 +6922,32 @@
         </p:spPr>
         <p:txBody>
           <a:bodyPr xmlns:a="http://schemas.openxmlformats.org/drawingml/2006/main" wrap="none" lIns="0" tIns="0" rIns="0" bIns="0" anchor="ctr">
-            <a:spAutoFit/>
+            <a:noAutofit/>
           </a:bodyPr>
           <a:lstStyle xmlns:a="http://schemas.openxmlformats.org/drawingml/2006/main"/>
           <a:p xmlns:a="http://schemas.openxmlformats.org/drawingml/2006/main">
             <a:pPr algn="l">
               <a:buNone/>
-            </a:pPr>
+              <a:defRPr sz="1800">
+                <a:solidFill>
+                  <a:srgbClr val="FFFFFF"/>
+                </a:solidFill>
+                <a:latin typeface="Calibri"/>
+                <a:ea typeface="Calibri"/>
+                <a:cs typeface="Calibri"/>
+              </a:defRPr>
+            </a:pPr>
+            <a:r>
+              <a:rPr sz="1800">
+                <a:solidFill>
+                  <a:srgbClr val="FFFFFF"/>
+                </a:solidFill>
+                <a:latin typeface="Calibri"/>
+                <a:ea typeface="Calibri"/>
+                <a:cs typeface="Calibri"/>
+              </a:rPr>
+              <a:t>{{agenda_item3}}</a:t>
+            </a:r>
             <a:endParaRPr sz="1010" b="1">
               <a:solidFill>
                 <a:srgbClr val="FFFFFF"/>
@@ -7042,7 +7120,7 @@
       </p:sp>
       <p:sp>
         <p:nvSpPr>
-          <p:cNvPr id="20" name="TextBox 19">
+          <p:cNvPr id="20" name="ctt:agenda_item4">
             <a:extLst xmlns:a="http://schemas.openxmlformats.org/drawingml/2006/main">
               <a:ext uri="{FF2B5EF4-FFF2-40B4-BE49-F238E27FC236}">
                 <a16:creationId xmlns:a16="http://schemas.microsoft.com/office/drawing/2014/main" id="{106C71E7-D8B3-4B6F-A24C-062214F30F8D}"/>
@@ -7056,8 +7134,8 @@
         </p:nvSpPr>
         <p:spPr>
           <a:xfrm xmlns:a="http://schemas.openxmlformats.org/drawingml/2006/main">
-            <a:off x="6986016" y="3012958"/>
-            <a:ext cx="65" cy="155427"/>
+            <a:off x="6986016" y="2847975"/>
+            <a:ext cx="4238625" cy="495300"/>
           </a:xfrm>
           <a:prstGeom xmlns:a="http://schemas.openxmlformats.org/drawingml/2006/main" prst="rect">
             <a:avLst/>
@@ -7066,13 +7144,32 @@
         </p:spPr>
         <p:txBody>
           <a:bodyPr xmlns:a="http://schemas.openxmlformats.org/drawingml/2006/main" wrap="none" lIns="0" tIns="0" rIns="0" bIns="0" anchor="ctr">
-            <a:spAutoFit/>
+            <a:noAutofit/>
           </a:bodyPr>
           <a:lstStyle xmlns:a="http://schemas.openxmlformats.org/drawingml/2006/main"/>
           <a:p xmlns:a="http://schemas.openxmlformats.org/drawingml/2006/main">
             <a:pPr algn="l">
               <a:buNone/>
-            </a:pPr>
+              <a:defRPr sz="1800">
+                <a:solidFill>
+                  <a:srgbClr val="FFFFFF"/>
+                </a:solidFill>
+                <a:latin typeface="Calibri"/>
+                <a:ea typeface="Calibri"/>
+                <a:cs typeface="Calibri"/>
+              </a:defRPr>
+            </a:pPr>
+            <a:r>
+              <a:rPr sz="1800">
+                <a:solidFill>
+                  <a:srgbClr val="FFFFFF"/>
+                </a:solidFill>
+                <a:latin typeface="Calibri"/>
+                <a:ea typeface="Calibri"/>
+                <a:cs typeface="Calibri"/>
+              </a:rPr>
+              <a:t>{{agenda_item4}}</a:t>
+            </a:r>
             <a:endParaRPr sz="1010" b="1">
               <a:solidFill>
                 <a:srgbClr val="FFFFFF"/>
@@ -7245,7 +7342,7 @@
       </p:sp>
       <p:sp>
         <p:nvSpPr>
-          <p:cNvPr id="24" name="TextBox 23">
+          <p:cNvPr id="24" name="ctt:agenda_item5">
             <a:extLst xmlns:a="http://schemas.openxmlformats.org/drawingml/2006/main">
               <a:ext uri="{FF2B5EF4-FFF2-40B4-BE49-F238E27FC236}">
                 <a16:creationId xmlns:a16="http://schemas.microsoft.com/office/drawing/2014/main" id="{6CB3575E-6697-43DD-AB5A-DDE435EB9D59}"/>
@@ -7259,8 +7356,8 @@
         </p:nvSpPr>
         <p:spPr>
           <a:xfrm xmlns:a="http://schemas.openxmlformats.org/drawingml/2006/main">
-            <a:off x="1335024" y="4201678"/>
-            <a:ext cx="65" cy="155427"/>
+            <a:off x="1335024" y="4038600"/>
+            <a:ext cx="4238625" cy="495300"/>
           </a:xfrm>
           <a:prstGeom xmlns:a="http://schemas.openxmlformats.org/drawingml/2006/main" prst="rect">
             <a:avLst/>
@@ -7269,13 +7366,32 @@
         </p:spPr>
         <p:txBody>
           <a:bodyPr xmlns:a="http://schemas.openxmlformats.org/drawingml/2006/main" wrap="none" lIns="0" tIns="0" rIns="0" bIns="0" anchor="ctr">
-            <a:spAutoFit/>
+            <a:noAutofit/>
           </a:bodyPr>
           <a:lstStyle xmlns:a="http://schemas.openxmlformats.org/drawingml/2006/main"/>
           <a:p xmlns:a="http://schemas.openxmlformats.org/drawingml/2006/main">
             <a:pPr algn="l">
               <a:buNone/>
-            </a:pPr>
+              <a:defRPr sz="1800">
+                <a:solidFill>
+                  <a:srgbClr val="FFFFFF"/>
+                </a:solidFill>
+                <a:latin typeface="Calibri"/>
+                <a:ea typeface="Calibri"/>
+                <a:cs typeface="Calibri"/>
+              </a:defRPr>
+            </a:pPr>
+            <a:r>
+              <a:rPr sz="1800">
+                <a:solidFill>
+                  <a:srgbClr val="FFFFFF"/>
+                </a:solidFill>
+                <a:latin typeface="Calibri"/>
+                <a:ea typeface="Calibri"/>
+                <a:cs typeface="Calibri"/>
+              </a:rPr>
+              <a:t>{{agenda_item5}}</a:t>
+            </a:r>
             <a:endParaRPr sz="1010" b="1">
               <a:solidFill>
                 <a:srgbClr val="FFFFFF"/>
@@ -7289,7 +7405,7 @@
       </p:sp>
       <p:sp>
         <p:nvSpPr>
-          <p:cNvPr id="29" name="TextBox 28">
+          <p:cNvPr id="29" name="ctt:agenda_context">
             <a:extLst xmlns:a="http://schemas.openxmlformats.org/drawingml/2006/main">
               <a:ext uri="{FF2B5EF4-FFF2-40B4-BE49-F238E27FC236}">
                 <a16:creationId xmlns:a16="http://schemas.microsoft.com/office/drawing/2014/main" id="{339AF3F1-4278-482C-92D9-E06043ADA145}"/>
@@ -7304,7 +7420,7 @@
         <p:spPr>
           <a:xfrm xmlns:a="http://schemas.openxmlformats.org/drawingml/2006/main">
             <a:off x="585216" y="6035040"/>
-            <a:ext cx="6675120" cy="228600"/>
+            <a:ext cx="10001250" cy="228600"/>
           </a:xfrm>
           <a:prstGeom xmlns:a="http://schemas.openxmlformats.org/drawingml/2006/main" prst="rect">
             <a:avLst/>
@@ -7329,14 +7445,14 @@
                 <a:ea typeface="Calibri"/>
                 <a:cs typeface="Calibri"/>
               </a:rPr>
-              <a:t>Observação / contexto da apresentação</a:t>
-            </a:r>
-          </a:p>
-        </p:txBody>
-      </p:sp>
-      <p:sp>
-        <p:nvSpPr>
-          <p:cNvPr id="30" name="TextBox 29">
+              <a:t>{{agenda_context}}</a:t>
+            </a:r>
+          </a:p>
+        </p:txBody>
+      </p:sp>
+      <p:sp>
+        <p:nvSpPr>
+          <p:cNvPr id="30" name="ctt:page">
             <a:extLst xmlns:a="http://schemas.openxmlformats.org/drawingml/2006/main">
               <a:ext uri="{FF2B5EF4-FFF2-40B4-BE49-F238E27FC236}">
                 <a16:creationId xmlns:a16="http://schemas.microsoft.com/office/drawing/2014/main" id="{A6A02662-D9FD-4E07-B4F6-A7D9D374E1AC}"/>
@@ -7376,7 +7492,7 @@
                 <a:ea typeface="Calibri"/>
                 <a:cs typeface="Calibri"/>
               </a:rPr>
-              <a:t>00 / 00</a:t>
+              <a:t>{{page}}</a:t>
             </a:r>
           </a:p>
         </p:txBody>
@@ -7412,7 +7528,7 @@
           <p:nvPr/>
         </p:nvPicPr>
         <p:blipFill>
-          <a:blip xmlns:r="http://schemas.openxmlformats.org/officeDocument/2006/relationships" xmlns:a="http://schemas.openxmlformats.org/drawingml/2006/main" r:embed="Rfa2d24b744f94098"/>
+          <a:blip xmlns:r="http://schemas.openxmlformats.org/officeDocument/2006/relationships" xmlns:a="http://schemas.openxmlformats.org/drawingml/2006/main" r:embed="R61f303d6ef014810"/>
           <a:stretch xmlns:a="http://schemas.openxmlformats.org/drawingml/2006/main">
             <a:fillRect l="0" t="0" r="0" b="0"/>
           </a:stretch>
@@ -8550,14 +8666,14 @@
       </p:grpSpPr>
       <p:pic>
         <p:nvPicPr>
-          <p:cNvPr id="30" name="Picture 1"/>
+          <p:cNvPr id="32" name="Picture 1"/>
           <p:cNvPicPr>
             <a:picLocks xmlns:a="http://schemas.openxmlformats.org/drawingml/2006/main" noChangeAspect="1"/>
           </p:cNvPicPr>
           <p:nvPr/>
         </p:nvPicPr>
         <p:blipFill>
-          <a:blip xmlns:r="http://schemas.openxmlformats.org/officeDocument/2006/relationships" xmlns:a="http://schemas.openxmlformats.org/drawingml/2006/main" r:embed="R70e2783457bd4ba9"/>
+          <a:blip xmlns:r="http://schemas.openxmlformats.org/officeDocument/2006/relationships" xmlns:a="http://schemas.openxmlformats.org/drawingml/2006/main" r:embed="R0836176b7e8a4e66"/>
           <a:stretch xmlns:a="http://schemas.openxmlformats.org/drawingml/2006/main">
             <a:fillRect l="0" t="0" r="0" b="0"/>
           </a:stretch>
@@ -8853,7 +8969,7 @@
       </p:sp>
       <p:graphicFrame>
         <p:nvGraphicFramePr>
-          <p:cNvPr id="36" name=""/>
+          <p:cNvPr id="38" name=""/>
           <p:cNvGraphicFramePr/>
           <p:nvPr/>
         </p:nvGraphicFramePr>
@@ -10008,6 +10124,7 @@
           <a:lstStyle xmlns:a="http://schemas.openxmlformats.org/drawingml/2006/main"/>
           <a:p xmlns:a="http://schemas.openxmlformats.org/drawingml/2006/main">
             <a:pPr>
+              <a:buNone/>
               <a:defRPr sz="1350">
                 <a:solidFill>
                   <a:srgbClr val="30515F"/>
@@ -10062,7 +10179,7 @@
           <p:nvPr/>
         </p:nvPicPr>
         <p:blipFill>
-          <a:blip xmlns:r="http://schemas.openxmlformats.org/officeDocument/2006/relationships" xmlns:a="http://schemas.openxmlformats.org/drawingml/2006/main" r:embed="Rd8149a3415ce444c"/>
+          <a:blip xmlns:r="http://schemas.openxmlformats.org/officeDocument/2006/relationships" xmlns:a="http://schemas.openxmlformats.org/drawingml/2006/main" r:embed="R91d0c864b4ee4941"/>
           <a:stretch xmlns:a="http://schemas.openxmlformats.org/drawingml/2006/main">
             <a:fillRect l="0" t="0" r="0" b="0"/>
           </a:stretch>
@@ -11091,7 +11208,7 @@
           <p:nvPr/>
         </p:nvPicPr>
         <p:blipFill>
-          <a:blip xmlns:r="http://schemas.openxmlformats.org/officeDocument/2006/relationships" xmlns:a="http://schemas.openxmlformats.org/drawingml/2006/main" r:embed="R12634766f3a04481"/>
+          <a:blip xmlns:r="http://schemas.openxmlformats.org/officeDocument/2006/relationships" xmlns:a="http://schemas.openxmlformats.org/drawingml/2006/main" r:embed="R4a94444b99c34ece"/>
           <a:stretch xmlns:a="http://schemas.openxmlformats.org/drawingml/2006/main">
             <a:fillRect l="0" t="0" r="0" b="0"/>
           </a:stretch>
@@ -12120,7 +12237,7 @@
           <p:nvPr/>
         </p:nvPicPr>
         <p:blipFill>
-          <a:blip xmlns:r="http://schemas.openxmlformats.org/officeDocument/2006/relationships" xmlns:a="http://schemas.openxmlformats.org/drawingml/2006/main" r:embed="Ra8a47a3dd3dd440e"/>
+          <a:blip xmlns:r="http://schemas.openxmlformats.org/officeDocument/2006/relationships" xmlns:a="http://schemas.openxmlformats.org/drawingml/2006/main" r:embed="R8bb626cee18646ea"/>
           <a:stretch xmlns:a="http://schemas.openxmlformats.org/drawingml/2006/main">
             <a:fillRect l="0" t="0" r="0" b="0"/>
           </a:stretch>
@@ -12959,7 +13076,7 @@
           <p:nvPr/>
         </p:nvPicPr>
         <p:blipFill>
-          <a:blip xmlns:r="http://schemas.openxmlformats.org/officeDocument/2006/relationships" xmlns:a="http://schemas.openxmlformats.org/drawingml/2006/main" r:embed="Rc8aab86bfd144893"/>
+          <a:blip xmlns:r="http://schemas.openxmlformats.org/officeDocument/2006/relationships" xmlns:a="http://schemas.openxmlformats.org/drawingml/2006/main" r:embed="R36d0faacb3a64252"/>
           <a:stretch xmlns:a="http://schemas.openxmlformats.org/drawingml/2006/main">
             <a:fillRect l="0" t="0" r="0" b="0"/>
           </a:stretch>

</xml_diff>

<commit_message>
feat: aprimora recorrência de setores e corrige exportação PPTX
Atualiza capa, unidade e motivação do trabalho no modelo CTT; destaca os menores intervalos e a atuação de outras frentes em áreas já iniciadas.

Adiciona evidências de talhões e cruza a frente informada na base com os equipamentos dos layouts, sem presumir autorização ou conclusão da área.

Organiza rastros por setor com passagens cronológicas lado a lado, períodos identificados e continuação quando necessário.

Corrige horzOverflow inválido no modelo e normaliza modelos antigos. Valida XML, referências e identificadores antes de liberar o download. Atualiza documentação e testes de regressão.

Validação: 79 testes Python aprovados, teste JavaScript da apresentação aprovado e 16 exportações das quatro unidades sem erros no validador Open XML Microsoft.
</commit_message>
<xml_diff>
--- a/templates/presentations/ctt_compact_template.pptx
+++ b/templates/presentations/ctt_compact_template.pptx
@@ -2,23 +2,25 @@
 <file path=ppt/presentation.xml><?xml version="1.0" encoding="utf-8"?>
 <p:presentation xmlns:p="http://schemas.openxmlformats.org/presentationml/2006/main">
   <p:sldMasterIdLst>
-    <p:sldMasterId xmlns:r="http://schemas.openxmlformats.org/officeDocument/2006/relationships" id="2147483648" r:id="Re024c75017784faf"/>
+    <p:sldMasterId xmlns:r="http://schemas.openxmlformats.org/officeDocument/2006/relationships" id="2147483648" r:id="Rcda7e89093b44d50"/>
   </p:sldMasterIdLst>
   <p:notesMasterIdLst>
-    <p:notesMasterId xmlns:r="http://schemas.openxmlformats.org/officeDocument/2006/relationships" r:id="R078f695a409d44c7"/>
+    <p:notesMasterId xmlns:r="http://schemas.openxmlformats.org/officeDocument/2006/relationships" r:id="R1452af0c8c72438a"/>
   </p:notesMasterIdLst>
   <p:sldIdLst>
-    <p:sldId xmlns:r="http://schemas.openxmlformats.org/officeDocument/2006/relationships" id="256" r:id="Rbfd00a9750e14619"/>
-    <p:sldId xmlns:r="http://schemas.openxmlformats.org/officeDocument/2006/relationships" id="257" r:id="Rc24d623e08ae475f"/>
-    <p:sldId xmlns:r="http://schemas.openxmlformats.org/officeDocument/2006/relationships" id="258" r:id="R89f83401bb3a4493"/>
-    <p:sldId xmlns:r="http://schemas.openxmlformats.org/officeDocument/2006/relationships" id="259" r:id="Rad9ba72c7cbe4743"/>
-    <p:sldId xmlns:r="http://schemas.openxmlformats.org/officeDocument/2006/relationships" id="260" r:id="R6bd4e5c7533e4419"/>
-    <p:sldId xmlns:r="http://schemas.openxmlformats.org/officeDocument/2006/relationships" id="261" r:id="Rb215d53d9f1c4910"/>
-    <p:sldId xmlns:r="http://schemas.openxmlformats.org/officeDocument/2006/relationships" id="262" r:id="R8f924f6b834848db"/>
-    <p:sldId xmlns:r="http://schemas.openxmlformats.org/officeDocument/2006/relationships" id="263" r:id="R124b2440d4a84139"/>
-    <p:sldId xmlns:r="http://schemas.openxmlformats.org/officeDocument/2006/relationships" id="264" r:id="R266d8fc5909a4b0d"/>
-    <p:sldId xmlns:r="http://schemas.openxmlformats.org/officeDocument/2006/relationships" id="265" r:id="R01049cdd97324794"/>
-    <p:sldId xmlns:r="http://schemas.openxmlformats.org/officeDocument/2006/relationships" id="266" r:id="Ra7410013a3fd4a7d"/>
+    <p:sldId xmlns:r="http://schemas.openxmlformats.org/officeDocument/2006/relationships" id="256" r:id="R04bcdab6e9184680"/>
+    <p:sldId xmlns:r="http://schemas.openxmlformats.org/officeDocument/2006/relationships" id="257" r:id="Red853d7af1a04daa"/>
+    <p:sldId xmlns:r="http://schemas.openxmlformats.org/officeDocument/2006/relationships" id="258" r:id="Rb1e16d6356464a54"/>
+    <p:sldId xmlns:r="http://schemas.openxmlformats.org/officeDocument/2006/relationships" id="259" r:id="Rdbf678cd07af48ce"/>
+    <p:sldId xmlns:r="http://schemas.openxmlformats.org/officeDocument/2006/relationships" id="260" r:id="Reb2fac2319c14cd0"/>
+    <p:sldId xmlns:r="http://schemas.openxmlformats.org/officeDocument/2006/relationships" id="261" r:id="R88515335e5944118"/>
+    <p:sldId xmlns:r="http://schemas.openxmlformats.org/officeDocument/2006/relationships" id="262" r:id="Ra9b67b15cc4e4c1d"/>
+    <p:sldId xmlns:r="http://schemas.openxmlformats.org/officeDocument/2006/relationships" id="263" r:id="Rfafa90aef3594de2"/>
+    <p:sldId xmlns:r="http://schemas.openxmlformats.org/officeDocument/2006/relationships" id="264" r:id="R317617b5b6894828"/>
+    <p:sldId xmlns:r="http://schemas.openxmlformats.org/officeDocument/2006/relationships" id="265" r:id="R5f44539dd0864add"/>
+    <p:sldId xmlns:r="http://schemas.openxmlformats.org/officeDocument/2006/relationships" id="266" r:id="R2bdda05040c643a5"/>
+    <p:sldId xmlns:r="http://schemas.openxmlformats.org/officeDocument/2006/relationships" id="267" r:id="Rc9c06f9e097b45a0"/>
+    <p:sldId xmlns:r="http://schemas.openxmlformats.org/officeDocument/2006/relationships" id="268" r:id="R2cc2bf41efed4a98"/>
   </p:sldIdLst>
   <p:sldSz cx="12192000" cy="6858000"/>
   <p:notesSz cx="6858000" cy="9144000"/>
@@ -749,6 +751,146 @@
 </p:notes>
 </file>
 
+<file path=ppt/notesSlides/notesSlide12.xml><?xml version="1.0" encoding="utf-8"?>
+<p:notes xmlns:p="http://schemas.openxmlformats.org/presentationml/2006/main">
+  <p:cSld>
+    <p:spTree>
+      <p:nvGrpSpPr>
+        <p:cNvPr id="1" name=""/>
+        <p:cNvGrpSpPr/>
+        <p:nvPr/>
+      </p:nvGrpSpPr>
+      <p:grpSpPr>
+        <a:xfrm xmlns:a="http://schemas.openxmlformats.org/drawingml/2006/main"/>
+      </p:grpSpPr>
+      <p:sp>
+        <p:nvSpPr>
+          <p:cNvPr id="2" name="Slide Image Placeholder 1"/>
+          <p:cNvSpPr>
+            <a:spLocks xmlns:a="http://schemas.openxmlformats.org/drawingml/2006/main" noGrp="1"/>
+          </p:cNvSpPr>
+          <p:nvPr>
+            <p:ph type="sldImg" idx="0"/>
+          </p:nvPr>
+        </p:nvSpPr>
+        <p:spPr/>
+      </p:sp>
+      <p:sp>
+        <p:nvSpPr>
+          <p:cNvPr id="3" name="Notes Placeholder 2"/>
+          <p:cNvSpPr>
+            <a:spLocks xmlns:a="http://schemas.openxmlformats.org/drawingml/2006/main" noGrp="1"/>
+          </p:cNvSpPr>
+          <p:nvPr>
+            <p:ph type="body" idx="1"/>
+          </p:nvPr>
+        </p:nvSpPr>
+        <p:spPr/>
+        <p:txBody>
+          <a:bodyPr xmlns:a="http://schemas.openxmlformats.org/drawingml/2006/main"/>
+          <a:lstStyle xmlns:a="http://schemas.openxmlformats.org/drawingml/2006/main"/>
+          <a:p xmlns:a="http://schemas.openxmlformats.org/drawingml/2006/main">
+            <a:r>
+              <a:t>{{notes}}</a:t>
+            </a:r>
+          </a:p>
+        </p:txBody>
+      </p:sp>
+      <p:sp>
+        <p:nvSpPr>
+          <p:cNvPr id="4" name="Slide Number Placeholder 3"/>
+          <p:cNvSpPr>
+            <a:spLocks xmlns:a="http://schemas.openxmlformats.org/drawingml/2006/main" noGrp="1"/>
+          </p:cNvSpPr>
+          <p:nvPr>
+            <p:ph type="sldNum" idx="5"/>
+          </p:nvPr>
+        </p:nvSpPr>
+        <p:spPr/>
+        <p:txBody>
+          <a:bodyPr xmlns:a="http://schemas.openxmlformats.org/drawingml/2006/main"/>
+          <a:lstStyle xmlns:a="http://schemas.openxmlformats.org/drawingml/2006/main"/>
+          <a:p xmlns:a="http://schemas.openxmlformats.org/drawingml/2006/main"/>
+        </p:txBody>
+      </p:sp>
+    </p:spTree>
+  </p:cSld>
+  <p:clrMapOvr>
+    <a:masterClrMapping xmlns:a="http://schemas.openxmlformats.org/drawingml/2006/main"/>
+  </p:clrMapOvr>
+</p:notes>
+</file>
+
+<file path=ppt/notesSlides/notesSlide13.xml><?xml version="1.0" encoding="utf-8"?>
+<p:notes xmlns:p="http://schemas.openxmlformats.org/presentationml/2006/main">
+  <p:cSld>
+    <p:spTree>
+      <p:nvGrpSpPr>
+        <p:cNvPr id="1" name=""/>
+        <p:cNvGrpSpPr/>
+        <p:nvPr/>
+      </p:nvGrpSpPr>
+      <p:grpSpPr>
+        <a:xfrm xmlns:a="http://schemas.openxmlformats.org/drawingml/2006/main"/>
+      </p:grpSpPr>
+      <p:sp>
+        <p:nvSpPr>
+          <p:cNvPr id="2" name="Slide Image Placeholder 1"/>
+          <p:cNvSpPr>
+            <a:spLocks xmlns:a="http://schemas.openxmlformats.org/drawingml/2006/main" noGrp="1"/>
+          </p:cNvSpPr>
+          <p:nvPr>
+            <p:ph type="sldImg" idx="0"/>
+          </p:nvPr>
+        </p:nvSpPr>
+        <p:spPr/>
+      </p:sp>
+      <p:sp>
+        <p:nvSpPr>
+          <p:cNvPr id="3" name="Notes Placeholder 2"/>
+          <p:cNvSpPr>
+            <a:spLocks xmlns:a="http://schemas.openxmlformats.org/drawingml/2006/main" noGrp="1"/>
+          </p:cNvSpPr>
+          <p:nvPr>
+            <p:ph type="body" idx="1"/>
+          </p:nvPr>
+        </p:nvSpPr>
+        <p:spPr/>
+        <p:txBody>
+          <a:bodyPr xmlns:a="http://schemas.openxmlformats.org/drawingml/2006/main"/>
+          <a:lstStyle xmlns:a="http://schemas.openxmlformats.org/drawingml/2006/main"/>
+          <a:p xmlns:a="http://schemas.openxmlformats.org/drawingml/2006/main">
+            <a:r>
+              <a:t>{{notes}}</a:t>
+            </a:r>
+          </a:p>
+        </p:txBody>
+      </p:sp>
+      <p:sp>
+        <p:nvSpPr>
+          <p:cNvPr id="4" name="Slide Number Placeholder 3"/>
+          <p:cNvSpPr>
+            <a:spLocks xmlns:a="http://schemas.openxmlformats.org/drawingml/2006/main" noGrp="1"/>
+          </p:cNvSpPr>
+          <p:nvPr>
+            <p:ph type="sldNum" idx="5"/>
+          </p:nvPr>
+        </p:nvSpPr>
+        <p:spPr/>
+        <p:txBody>
+          <a:bodyPr xmlns:a="http://schemas.openxmlformats.org/drawingml/2006/main"/>
+          <a:lstStyle xmlns:a="http://schemas.openxmlformats.org/drawingml/2006/main"/>
+          <a:p xmlns:a="http://schemas.openxmlformats.org/drawingml/2006/main"/>
+        </p:txBody>
+      </p:sp>
+    </p:spTree>
+  </p:cSld>
+  <p:clrMapOvr>
+    <a:masterClrMapping xmlns:a="http://schemas.openxmlformats.org/drawingml/2006/main"/>
+  </p:clrMapOvr>
+</p:notes>
+</file>
+
 <file path=ppt/notesSlides/notesSlide2.xml><?xml version="1.0" encoding="utf-8"?>
 <p:notes xmlns:p="http://schemas.openxmlformats.org/presentationml/2006/main">
   <p:cSld>
@@ -4273,17 +4415,17 @@
   </p:cSld>
   <p:clrMap bg1="lt1" tx1="dk1" bg2="lt2" tx2="dk2" accent1="accent1" accent2="accent2" accent3="accent3" accent4="accent4" accent5="accent5" accent6="accent6" hlink="hlink" folHlink="folHlink"/>
   <p:sldLayoutIdLst>
-    <p:sldLayoutId xmlns:r="http://schemas.openxmlformats.org/officeDocument/2006/relationships" id="2147483649" r:id="R3bee3e0d8a1d4f79"/>
-    <p:sldLayoutId xmlns:r="http://schemas.openxmlformats.org/officeDocument/2006/relationships" id="2147483650" r:id="R35d6cf992ba04891"/>
-    <p:sldLayoutId xmlns:r="http://schemas.openxmlformats.org/officeDocument/2006/relationships" id="2147483651" r:id="Ra3d06c17d3ab471a"/>
-    <p:sldLayoutId xmlns:r="http://schemas.openxmlformats.org/officeDocument/2006/relationships" id="2147483652" r:id="R2ce995e890b44b20"/>
-    <p:sldLayoutId xmlns:r="http://schemas.openxmlformats.org/officeDocument/2006/relationships" id="2147483653" r:id="R63c336c5e9914022"/>
-    <p:sldLayoutId xmlns:r="http://schemas.openxmlformats.org/officeDocument/2006/relationships" id="2147483654" r:id="R35cef4fdfc204c25"/>
-    <p:sldLayoutId xmlns:r="http://schemas.openxmlformats.org/officeDocument/2006/relationships" id="2147483655" r:id="R84590e3f05954f77"/>
-    <p:sldLayoutId xmlns:r="http://schemas.openxmlformats.org/officeDocument/2006/relationships" id="2147483656" r:id="R406860f5603c440f"/>
-    <p:sldLayoutId xmlns:r="http://schemas.openxmlformats.org/officeDocument/2006/relationships" id="2147483657" r:id="R943f0724fad14e73"/>
-    <p:sldLayoutId xmlns:r="http://schemas.openxmlformats.org/officeDocument/2006/relationships" id="2147483658" r:id="Rdecd5da36b4f4311"/>
-    <p:sldLayoutId xmlns:r="http://schemas.openxmlformats.org/officeDocument/2006/relationships" id="2147483659" r:id="R3aeb2412c7254e65"/>
+    <p:sldLayoutId xmlns:r="http://schemas.openxmlformats.org/officeDocument/2006/relationships" id="2147483649" r:id="R6f8d26b6c7924343"/>
+    <p:sldLayoutId xmlns:r="http://schemas.openxmlformats.org/officeDocument/2006/relationships" id="2147483650" r:id="Red1c88dfd5b04014"/>
+    <p:sldLayoutId xmlns:r="http://schemas.openxmlformats.org/officeDocument/2006/relationships" id="2147483651" r:id="R2158e9da6fdf4578"/>
+    <p:sldLayoutId xmlns:r="http://schemas.openxmlformats.org/officeDocument/2006/relationships" id="2147483652" r:id="R1fa43e1ac5b64548"/>
+    <p:sldLayoutId xmlns:r="http://schemas.openxmlformats.org/officeDocument/2006/relationships" id="2147483653" r:id="Rd235e35502244cad"/>
+    <p:sldLayoutId xmlns:r="http://schemas.openxmlformats.org/officeDocument/2006/relationships" id="2147483654" r:id="R462d9438cd0b4f75"/>
+    <p:sldLayoutId xmlns:r="http://schemas.openxmlformats.org/officeDocument/2006/relationships" id="2147483655" r:id="Reb5621f66802423a"/>
+    <p:sldLayoutId xmlns:r="http://schemas.openxmlformats.org/officeDocument/2006/relationships" id="2147483656" r:id="R8884dd6f03fa4eb0"/>
+    <p:sldLayoutId xmlns:r="http://schemas.openxmlformats.org/officeDocument/2006/relationships" id="2147483657" r:id="Rf90162f78bde4161"/>
+    <p:sldLayoutId xmlns:r="http://schemas.openxmlformats.org/officeDocument/2006/relationships" id="2147483658" r:id="Raacffd38c87947eb"/>
+    <p:sldLayoutId xmlns:r="http://schemas.openxmlformats.org/officeDocument/2006/relationships" id="2147483659" r:id="R0c13028769f44ceb"/>
   </p:sldLayoutIdLst>
   <p:txStyles>
     <p:titleStyle>
@@ -4833,7 +4975,7 @@
           <p:nvPr/>
         </p:nvPicPr>
         <p:blipFill>
-          <a:blip xmlns:r="http://schemas.openxmlformats.org/officeDocument/2006/relationships" xmlns:a="http://schemas.openxmlformats.org/drawingml/2006/main" r:embed="R6c3ea812fefc4026"/>
+          <a:blip xmlns:r="http://schemas.openxmlformats.org/officeDocument/2006/relationships" xmlns:a="http://schemas.openxmlformats.org/drawingml/2006/main" r:embed="Rb8769b0c31d848ff"/>
           <a:stretch xmlns:a="http://schemas.openxmlformats.org/drawingml/2006/main">
             <a:fillRect l="0" t="0" r="0" b="0"/>
           </a:stretch>
@@ -5209,7 +5351,7 @@
           <p:nvPr/>
         </p:nvPicPr>
         <p:blipFill>
-          <a:blip xmlns:r="http://schemas.openxmlformats.org/officeDocument/2006/relationships" xmlns:a="http://schemas.openxmlformats.org/drawingml/2006/main" r:embed="R3b3b0000ab134f44"/>
+          <a:blip xmlns:r="http://schemas.openxmlformats.org/officeDocument/2006/relationships" xmlns:a="http://schemas.openxmlformats.org/drawingml/2006/main" r:embed="R95c187c7038c44eb"/>
           <a:stretch xmlns:a="http://schemas.openxmlformats.org/drawingml/2006/main">
             <a:fillRect l="0" t="0" r="0" b="0"/>
           </a:stretch>
@@ -5342,14 +5484,14 @@
       </p:grpSpPr>
       <p:pic>
         <p:nvPicPr>
-          <p:cNvPr id="32" name="Picture 1"/>
+          <p:cNvPr id="37" name="Picture 1"/>
           <p:cNvPicPr>
             <a:picLocks xmlns:a="http://schemas.openxmlformats.org/drawingml/2006/main" noChangeAspect="1"/>
           </p:cNvPicPr>
           <p:nvPr/>
         </p:nvPicPr>
         <p:blipFill>
-          <a:blip xmlns:r="http://schemas.openxmlformats.org/officeDocument/2006/relationships" xmlns:a="http://schemas.openxmlformats.org/drawingml/2006/main" r:embed="R1a1ed922cf914549"/>
+          <a:blip xmlns:r="http://schemas.openxmlformats.org/officeDocument/2006/relationships" xmlns:a="http://schemas.openxmlformats.org/drawingml/2006/main" r:embed="R108c19f595294467"/>
           <a:stretch xmlns:a="http://schemas.openxmlformats.org/drawingml/2006/main">
             <a:fillRect l="0" t="0" r="0" b="0"/>
           </a:stretch>
@@ -5364,53 +5506,6 @@
           </a:prstGeom>
         </p:spPr>
       </p:pic>
-      <p:sp>
-        <p:nvSpPr>
-          <p:cNvPr id="21" name="ctt:unused">
-            <a:extLst xmlns:a="http://schemas.openxmlformats.org/drawingml/2006/main">
-              <a:ext uri="{FF2B5EF4-FFF2-40B4-BE49-F238E27FC236}">
-                <a16:creationId xmlns:a16="http://schemas.microsoft.com/office/drawing/2014/main" id="{7F566525-AEC8-9E0E-8236-1411DEF6D02E}"/>
-              </a:ext>
-            </a:extLst>
-          </p:cNvPr>
-          <p:cNvSpPr>
-            <a:spLocks xmlns:a="http://schemas.openxmlformats.org/drawingml/2006/main" noGrp="1"/>
-          </p:cNvSpPr>
-          <p:nvPr/>
-        </p:nvSpPr>
-        <p:spPr>
-          <a:xfrm xmlns:a="http://schemas.openxmlformats.org/drawingml/2006/main">
-            <a:off x="566928" y="932688"/>
-            <a:ext cx="365760" cy="274320"/>
-          </a:xfrm>
-          <a:prstGeom xmlns:a="http://schemas.openxmlformats.org/drawingml/2006/main" prst="rect">
-            <a:avLst/>
-          </a:prstGeom>
-          <a:noFill xmlns:a="http://schemas.openxmlformats.org/drawingml/2006/main"/>
-        </p:spPr>
-        <p:txBody>
-          <a:bodyPr xmlns:a="http://schemas.openxmlformats.org/drawingml/2006/main" wrap="none" lIns="0" tIns="0" rIns="0" bIns="0" anchor="ctr">
-            <a:spAutoFit/>
-          </a:bodyPr>
-          <a:lstStyle xmlns:a="http://schemas.openxmlformats.org/drawingml/2006/main"/>
-          <a:p xmlns:a="http://schemas.openxmlformats.org/drawingml/2006/main">
-            <a:pPr algn="ctr">
-              <a:buNone/>
-            </a:pPr>
-            <a:r>
-              <a:rPr sz="819" b="1">
-                <a:solidFill>
-                  <a:srgbClr val="FFFFFF"/>
-                </a:solidFill>
-                <a:latin typeface="Calibri"/>
-                <a:ea typeface="Calibri"/>
-                <a:cs typeface="Calibri"/>
-              </a:rPr>
-              <a:t/>
-            </a:r>
-          </a:p>
-        </p:txBody>
-      </p:sp>
       <p:sp>
         <p:nvSpPr>
           <p:cNvPr id="23" name="ctt:summary_title">
@@ -5529,64 +5624,6 @@
       </p:sp>
       <p:sp>
         <p:nvSpPr>
-          <p:cNvPr id="25" name="ctt:summary_body">
-            <a:extLst xmlns:a="http://schemas.openxmlformats.org/drawingml/2006/main">
-              <a:ext uri="{FF2B5EF4-FFF2-40B4-BE49-F238E27FC236}">
-                <a16:creationId xmlns:a16="http://schemas.microsoft.com/office/drawing/2014/main" id="{5B6F7839-FF01-4ADE-B42B-F715E02A1023}"/>
-              </a:ext>
-            </a:extLst>
-          </p:cNvPr>
-          <p:cNvSpPr>
-            <a:spLocks xmlns:a="http://schemas.openxmlformats.org/drawingml/2006/main" noGrp="1"/>
-          </p:cNvSpPr>
-          <p:nvPr/>
-        </p:nvSpPr>
-        <p:spPr>
-          <a:xfrm xmlns:a="http://schemas.openxmlformats.org/drawingml/2006/main">
-            <a:off x="571500" y="1143000"/>
-            <a:ext cx="11001375" cy="4667250"/>
-          </a:xfrm>
-          <a:prstGeom xmlns:a="http://schemas.openxmlformats.org/drawingml/2006/main" prst="rect">
-            <a:avLst/>
-          </a:prstGeom>
-          <a:noFill xmlns:a="http://schemas.openxmlformats.org/drawingml/2006/main"/>
-          <a:ln xmlns:a="http://schemas.openxmlformats.org/drawingml/2006/main" w="0">
-            <a:noFill/>
-          </a:ln>
-        </p:spPr>
-        <p:txBody>
-          <a:bodyPr xmlns:a="http://schemas.openxmlformats.org/drawingml/2006/main">
-            <a:noAutofit/>
-          </a:bodyPr>
-          <a:lstStyle xmlns:a="http://schemas.openxmlformats.org/drawingml/2006/main"/>
-          <a:p xmlns:a="http://schemas.openxmlformats.org/drawingml/2006/main">
-            <a:pPr algn="l">
-              <a:buNone/>
-              <a:defRPr sz="1875" b="0">
-                <a:solidFill>
-                  <a:srgbClr val="30515F"/>
-                </a:solidFill>
-                <a:latin typeface="Calibri"/>
-                <a:ea typeface="Calibri"/>
-                <a:cs typeface="Calibri"/>
-              </a:defRPr>
-            </a:pPr>
-            <a:r>
-              <a:rPr sz="1875" b="0">
-                <a:solidFill>
-                  <a:srgbClr val="30515F"/>
-                </a:solidFill>
-                <a:latin typeface="Calibri"/>
-                <a:ea typeface="Calibri"/>
-                <a:cs typeface="Calibri"/>
-              </a:rPr>
-              <a:t/>
-            </a:r>
-          </a:p>
-        </p:txBody>
-      </p:sp>
-      <p:sp>
-        <p:nvSpPr>
           <p:cNvPr id="26" name="ctt:footer">
             <a:extLst xmlns:a="http://schemas.openxmlformats.org/drawingml/2006/main">
               <a:ext uri="{FF2B5EF4-FFF2-40B4-BE49-F238E27FC236}">
@@ -5703,59 +5740,6 @@
       </p:sp>
       <p:sp>
         <p:nvSpPr>
-          <p:cNvPr id="29" name="ctt:trace_picture">
-            <a:extLst xmlns:a="http://schemas.openxmlformats.org/drawingml/2006/main">
-              <a:ext uri="{FF2B5EF4-FFF2-40B4-BE49-F238E27FC236}">
-                <a16:creationId xmlns:a16="http://schemas.microsoft.com/office/drawing/2014/main" id="{D41BFD71-53E9-4443-A0BC-D0EB988D6C46}"/>
-              </a:ext>
-            </a:extLst>
-          </p:cNvPr>
-          <p:cNvSpPr>
-            <a:spLocks xmlns:a="http://schemas.openxmlformats.org/drawingml/2006/main" noGrp="1"/>
-          </p:cNvSpPr>
-          <p:nvPr>
-            <p:ph idx="0"/>
-          </p:nvPr>
-        </p:nvSpPr>
-        <p:spPr>
-          <a:xfrm xmlns:a="http://schemas.openxmlformats.org/drawingml/2006/main">
-            <a:off x="571500" y="1714500"/>
-            <a:ext cx="11001375" cy="3905250"/>
-          </a:xfrm>
-        </p:spPr>
-        <p:txBody>
-          <a:bodyPr xmlns:a="http://schemas.openxmlformats.org/drawingml/2006/main" anchor="ctr">
-            <a:noAutofit/>
-          </a:bodyPr>
-          <a:lstStyle xmlns:a="http://schemas.openxmlformats.org/drawingml/2006/main"/>
-          <a:p xmlns:a="http://schemas.openxmlformats.org/drawingml/2006/main">
-            <a:pPr algn="ctr">
-              <a:buNone/>
-              <a:defRPr sz="2100">
-                <a:solidFill>
-                  <a:srgbClr val="7F7F7F"/>
-                </a:solidFill>
-                <a:latin typeface="Calibri"/>
-                <a:ea typeface="Calibri"/>
-                <a:cs typeface="Calibri"/>
-              </a:defRPr>
-            </a:pPr>
-            <a:r>
-              <a:rPr sz="2100">
-                <a:solidFill>
-                  <a:srgbClr val="7F7F7F"/>
-                </a:solidFill>
-                <a:latin typeface="Calibri"/>
-                <a:ea typeface="Calibri"/>
-                <a:cs typeface="Calibri"/>
-              </a:rPr>
-              <a:t>{{trace_picture}}</a:t>
-            </a:r>
-          </a:p>
-        </p:txBody>
-      </p:sp>
-      <p:sp>
-        <p:nvSpPr>
           <p:cNvPr id="30" name="ctt:trace_caption">
             <a:extLst xmlns:a="http://schemas.openxmlformats.org/drawingml/2006/main">
               <a:ext uri="{FF2B5EF4-FFF2-40B4-BE49-F238E27FC236}">
@@ -5808,6 +5792,1619 @@
                 <a:cs typeface="Calibri"/>
               </a:rPr>
               <a:t>{{trace_caption}}</a:t>
+            </a:r>
+          </a:p>
+        </p:txBody>
+      </p:sp>
+      <p:sp>
+        <p:nvSpPr>
+          <p:cNvPr id="32" name="ctt:trace_passage_1">
+            <a:extLst xmlns:a="http://schemas.openxmlformats.org/drawingml/2006/main">
+              <a:ext uri="{FF2B5EF4-FFF2-40B4-BE49-F238E27FC236}">
+                <a16:creationId xmlns:a16="http://schemas.microsoft.com/office/drawing/2014/main" id="{997E1833-CCB3-4F65-8C97-25275A1FD676}"/>
+              </a:ext>
+            </a:extLst>
+          </p:cNvPr>
+          <p:cNvSpPr>
+            <a:spLocks xmlns:a="http://schemas.openxmlformats.org/drawingml/2006/main" noGrp="1"/>
+          </p:cNvSpPr>
+          <p:nvPr/>
+        </p:nvSpPr>
+        <p:spPr>
+          <a:xfrm xmlns:a="http://schemas.openxmlformats.org/drawingml/2006/main">
+            <a:off x="571500" y="1666875"/>
+            <a:ext cx="5386388" cy="647700"/>
+          </a:xfrm>
+          <a:prstGeom xmlns:a="http://schemas.openxmlformats.org/drawingml/2006/main" prst="rect">
+            <a:avLst/>
+          </a:prstGeom>
+          <a:noFill xmlns:a="http://schemas.openxmlformats.org/drawingml/2006/main"/>
+          <a:ln xmlns:a="http://schemas.openxmlformats.org/drawingml/2006/main" w="0">
+            <a:noFill/>
+          </a:ln>
+        </p:spPr>
+        <p:txBody>
+          <a:bodyPr xmlns:a="http://schemas.openxmlformats.org/drawingml/2006/main" anchor="ctr">
+            <a:noAutofit/>
+          </a:bodyPr>
+          <a:lstStyle xmlns:a="http://schemas.openxmlformats.org/drawingml/2006/main"/>
+          <a:p xmlns:a="http://schemas.openxmlformats.org/drawingml/2006/main">
+            <a:pPr algn="ctr">
+              <a:buNone/>
+              <a:defRPr sz="1650" b="1">
+                <a:solidFill>
+                  <a:srgbClr val="30515F"/>
+                </a:solidFill>
+                <a:latin typeface="Calibri"/>
+                <a:ea typeface="Calibri"/>
+                <a:cs typeface="Calibri"/>
+              </a:defRPr>
+            </a:pPr>
+            <a:r>
+              <a:rPr sz="1650" b="1">
+                <a:solidFill>
+                  <a:srgbClr val="30515F"/>
+                </a:solidFill>
+                <a:latin typeface="Calibri"/>
+                <a:ea typeface="Calibri"/>
+                <a:cs typeface="Calibri"/>
+              </a:rPr>
+              <a:t>{{trace_passage_1}}</a:t>
+            </a:r>
+          </a:p>
+        </p:txBody>
+      </p:sp>
+      <p:sp>
+        <p:nvSpPr>
+          <p:cNvPr id="33" name="ctt:trace_picture_1">
+            <a:extLst xmlns:a="http://schemas.openxmlformats.org/drawingml/2006/main">
+              <a:ext uri="{FF2B5EF4-FFF2-40B4-BE49-F238E27FC236}">
+                <a16:creationId xmlns:a16="http://schemas.microsoft.com/office/drawing/2014/main" id="{65AEADC6-0C56-4D2B-AD63-0E4D52A5675E}"/>
+              </a:ext>
+            </a:extLst>
+          </p:cNvPr>
+          <p:cNvSpPr>
+            <a:spLocks xmlns:a="http://schemas.openxmlformats.org/drawingml/2006/main" noGrp="1"/>
+          </p:cNvSpPr>
+          <p:nvPr>
+            <p:ph idx="0"/>
+          </p:nvPr>
+        </p:nvSpPr>
+        <p:spPr>
+          <a:xfrm xmlns:a="http://schemas.openxmlformats.org/drawingml/2006/main">
+            <a:off x="571500" y="2381250"/>
+            <a:ext cx="5386388" cy="3238500"/>
+          </a:xfrm>
+        </p:spPr>
+        <p:txBody>
+          <a:bodyPr xmlns:a="http://schemas.openxmlformats.org/drawingml/2006/main" anchor="ctr">
+            <a:noAutofit/>
+          </a:bodyPr>
+          <a:lstStyle xmlns:a="http://schemas.openxmlformats.org/drawingml/2006/main"/>
+          <a:p xmlns:a="http://schemas.openxmlformats.org/drawingml/2006/main">
+            <a:pPr algn="ctr">
+              <a:buNone/>
+              <a:defRPr sz="1800">
+                <a:solidFill>
+                  <a:srgbClr val="7F7F7F"/>
+                </a:solidFill>
+                <a:latin typeface="Calibri"/>
+                <a:ea typeface="Calibri"/>
+                <a:cs typeface="Calibri"/>
+              </a:defRPr>
+            </a:pPr>
+            <a:r>
+              <a:rPr sz="1800">
+                <a:solidFill>
+                  <a:srgbClr val="7F7F7F"/>
+                </a:solidFill>
+                <a:latin typeface="Calibri"/>
+                <a:ea typeface="Calibri"/>
+                <a:cs typeface="Calibri"/>
+              </a:rPr>
+              <a:t>{{trace_picture_1}}</a:t>
+            </a:r>
+          </a:p>
+        </p:txBody>
+      </p:sp>
+      <p:sp>
+        <p:nvSpPr>
+          <p:cNvPr id="34" name="ctt:trace_passage_2">
+            <a:extLst xmlns:a="http://schemas.openxmlformats.org/drawingml/2006/main">
+              <a:ext uri="{FF2B5EF4-FFF2-40B4-BE49-F238E27FC236}">
+                <a16:creationId xmlns:a16="http://schemas.microsoft.com/office/drawing/2014/main" id="{576B3CFB-F1AB-4B88-96E9-585899A64D54}"/>
+              </a:ext>
+            </a:extLst>
+          </p:cNvPr>
+          <p:cNvSpPr>
+            <a:spLocks xmlns:a="http://schemas.openxmlformats.org/drawingml/2006/main" noGrp="1"/>
+          </p:cNvSpPr>
+          <p:nvPr/>
+        </p:nvSpPr>
+        <p:spPr>
+          <a:xfrm xmlns:a="http://schemas.openxmlformats.org/drawingml/2006/main">
+            <a:off x="6186488" y="1666875"/>
+            <a:ext cx="5386388" cy="647700"/>
+          </a:xfrm>
+          <a:prstGeom xmlns:a="http://schemas.openxmlformats.org/drawingml/2006/main" prst="rect">
+            <a:avLst/>
+          </a:prstGeom>
+          <a:noFill xmlns:a="http://schemas.openxmlformats.org/drawingml/2006/main"/>
+          <a:ln xmlns:a="http://schemas.openxmlformats.org/drawingml/2006/main" w="0">
+            <a:noFill/>
+          </a:ln>
+        </p:spPr>
+        <p:txBody>
+          <a:bodyPr xmlns:a="http://schemas.openxmlformats.org/drawingml/2006/main" anchor="ctr">
+            <a:noAutofit/>
+          </a:bodyPr>
+          <a:lstStyle xmlns:a="http://schemas.openxmlformats.org/drawingml/2006/main"/>
+          <a:p xmlns:a="http://schemas.openxmlformats.org/drawingml/2006/main">
+            <a:pPr algn="ctr">
+              <a:buNone/>
+              <a:defRPr sz="1650" b="1">
+                <a:solidFill>
+                  <a:srgbClr val="30515F"/>
+                </a:solidFill>
+                <a:latin typeface="Calibri"/>
+                <a:ea typeface="Calibri"/>
+                <a:cs typeface="Calibri"/>
+              </a:defRPr>
+            </a:pPr>
+            <a:r>
+              <a:rPr sz="1650" b="1">
+                <a:solidFill>
+                  <a:srgbClr val="30515F"/>
+                </a:solidFill>
+                <a:latin typeface="Calibri"/>
+                <a:ea typeface="Calibri"/>
+                <a:cs typeface="Calibri"/>
+              </a:rPr>
+              <a:t>{{trace_passage_2}}</a:t>
+            </a:r>
+          </a:p>
+        </p:txBody>
+      </p:sp>
+      <p:sp>
+        <p:nvSpPr>
+          <p:cNvPr id="35" name="ctt:trace_picture_2">
+            <a:extLst xmlns:a="http://schemas.openxmlformats.org/drawingml/2006/main">
+              <a:ext uri="{FF2B5EF4-FFF2-40B4-BE49-F238E27FC236}">
+                <a16:creationId xmlns:a16="http://schemas.microsoft.com/office/drawing/2014/main" id="{F3DC5712-6A4D-4206-B08D-81D144410FCF}"/>
+              </a:ext>
+            </a:extLst>
+          </p:cNvPr>
+          <p:cNvSpPr>
+            <a:spLocks xmlns:a="http://schemas.openxmlformats.org/drawingml/2006/main" noGrp="1"/>
+          </p:cNvSpPr>
+          <p:nvPr>
+            <p:ph idx="1"/>
+          </p:nvPr>
+        </p:nvSpPr>
+        <p:spPr>
+          <a:xfrm xmlns:a="http://schemas.openxmlformats.org/drawingml/2006/main">
+            <a:off x="6186488" y="2381250"/>
+            <a:ext cx="5386388" cy="3238500"/>
+          </a:xfrm>
+        </p:spPr>
+        <p:txBody>
+          <a:bodyPr xmlns:a="http://schemas.openxmlformats.org/drawingml/2006/main" anchor="ctr">
+            <a:noAutofit/>
+          </a:bodyPr>
+          <a:lstStyle xmlns:a="http://schemas.openxmlformats.org/drawingml/2006/main"/>
+          <a:p xmlns:a="http://schemas.openxmlformats.org/drawingml/2006/main">
+            <a:pPr algn="ctr">
+              <a:buNone/>
+              <a:defRPr sz="1800">
+                <a:solidFill>
+                  <a:srgbClr val="7F7F7F"/>
+                </a:solidFill>
+                <a:latin typeface="Calibri"/>
+                <a:ea typeface="Calibri"/>
+                <a:cs typeface="Calibri"/>
+              </a:defRPr>
+            </a:pPr>
+            <a:r>
+              <a:rPr sz="1800">
+                <a:solidFill>
+                  <a:srgbClr val="7F7F7F"/>
+                </a:solidFill>
+                <a:latin typeface="Calibri"/>
+                <a:ea typeface="Calibri"/>
+                <a:cs typeface="Calibri"/>
+              </a:rPr>
+              <a:t>{{trace_picture_2}}</a:t>
+            </a:r>
+          </a:p>
+        </p:txBody>
+      </p:sp>
+    </p:spTree>
+    <p:extLst>
+      <p:ext uri="{BB962C8B-B14F-4D97-AF65-F5344CB8AC3E}">
+        <p14:creationId xmlns:p14="http://schemas.microsoft.com/office/powerpoint/2010/main" val="3470110939"/>
+      </p:ext>
+    </p:extLst>
+  </p:cSld>
+</p:sld>
+</file>
+
+<file path=ppt/slides/slide12.xml><?xml version="1.0" encoding="utf-8"?>
+<p:sld xmlns:p="http://schemas.openxmlformats.org/presentationml/2006/main">
+  <p:cSld>
+    <p:spTree>
+      <p:nvGrpSpPr>
+        <p:cNvPr id="1" name=""/>
+        <p:cNvGrpSpPr/>
+        <p:nvPr/>
+      </p:nvGrpSpPr>
+      <p:grpSpPr>
+        <a:xfrm xmlns:a="http://schemas.openxmlformats.org/drawingml/2006/main"/>
+      </p:grpSpPr>
+      <p:pic>
+        <p:nvPicPr>
+          <p:cNvPr id="27" name="Picture 1"/>
+          <p:cNvPicPr>
+            <a:picLocks xmlns:a="http://schemas.openxmlformats.org/drawingml/2006/main" noChangeAspect="1"/>
+          </p:cNvPicPr>
+          <p:nvPr/>
+        </p:nvPicPr>
+        <p:blipFill>
+          <a:blip xmlns:r="http://schemas.openxmlformats.org/officeDocument/2006/relationships" xmlns:a="http://schemas.openxmlformats.org/drawingml/2006/main" r:embed="Rac312952c0c74be1"/>
+          <a:stretch xmlns:a="http://schemas.openxmlformats.org/drawingml/2006/main">
+            <a:fillRect l="0" t="0" r="0" b="0"/>
+          </a:stretch>
+        </p:blipFill>
+        <p:spPr>
+          <a:xfrm xmlns:a="http://schemas.openxmlformats.org/drawingml/2006/main">
+            <a:off x="0" y="0"/>
+            <a:ext cx="12191999" cy="6858000"/>
+          </a:xfrm>
+          <a:prstGeom xmlns:a="http://schemas.openxmlformats.org/drawingml/2006/main" prst="rect">
+            <a:avLst/>
+          </a:prstGeom>
+        </p:spPr>
+      </p:pic>
+      <p:sp>
+        <p:nvSpPr>
+          <p:cNvPr id="3" name="ctt:detail_title">
+            <a:extLst xmlns:a="http://schemas.openxmlformats.org/drawingml/2006/main">
+              <a:ext uri="{FF2B5EF4-FFF2-40B4-BE49-F238E27FC236}">
+                <a16:creationId xmlns:a16="http://schemas.microsoft.com/office/drawing/2014/main" id="{384A374C-B209-4F05-8C45-17AEAA117A70}"/>
+              </a:ext>
+            </a:extLst>
+          </p:cNvPr>
+          <p:cNvSpPr>
+            <a:spLocks xmlns:a="http://schemas.openxmlformats.org/drawingml/2006/main" noGrp="1"/>
+          </p:cNvSpPr>
+          <p:nvPr/>
+        </p:nvSpPr>
+        <p:spPr>
+          <a:xfrm xmlns:a="http://schemas.openxmlformats.org/drawingml/2006/main">
+            <a:off x="457200" y="109728"/>
+            <a:ext cx="10104120" cy="484632"/>
+          </a:xfrm>
+          <a:prstGeom xmlns:a="http://schemas.openxmlformats.org/drawingml/2006/main" prst="rect">
+            <a:avLst/>
+          </a:prstGeom>
+          <a:noFill xmlns:a="http://schemas.openxmlformats.org/drawingml/2006/main"/>
+        </p:spPr>
+        <p:txBody>
+          <a:bodyPr xmlns:a="http://schemas.openxmlformats.org/drawingml/2006/main" wrap="none" lIns="0" tIns="0" rIns="0" bIns="0" anchor="ctr">
+            <a:spAutoFit/>
+          </a:bodyPr>
+          <a:lstStyle xmlns:a="http://schemas.openxmlformats.org/drawingml/2006/main"/>
+          <a:p xmlns:a="http://schemas.openxmlformats.org/drawingml/2006/main">
+            <a:pPr algn="l">
+              <a:buNone/>
+            </a:pPr>
+            <a:r>
+              <a:rPr sz="2350" b="1">
+                <a:solidFill>
+                  <a:srgbClr val="76B82A"/>
+                </a:solidFill>
+                <a:latin typeface="Calibri Light"/>
+                <a:ea typeface="Calibri Light"/>
+                <a:cs typeface="Calibri Light"/>
+              </a:rPr>
+              <a:t>{{detail_title}}</a:t>
+            </a:r>
+          </a:p>
+        </p:txBody>
+      </p:sp>
+      <p:sp>
+        <p:nvSpPr>
+          <p:cNvPr id="4" name="Rounded Rectangle 3">
+            <a:extLst xmlns:a="http://schemas.openxmlformats.org/drawingml/2006/main">
+              <a:ext uri="{FF2B5EF4-FFF2-40B4-BE49-F238E27FC236}">
+                <a16:creationId xmlns:a16="http://schemas.microsoft.com/office/drawing/2014/main" id="{2A8D7DE2-9F35-4F6D-B954-848E9ABB11AF}"/>
+              </a:ext>
+            </a:extLst>
+          </p:cNvPr>
+          <p:cNvSpPr>
+            <a:spLocks xmlns:a="http://schemas.openxmlformats.org/drawingml/2006/main" noGrp="1"/>
+          </p:cNvSpPr>
+          <p:nvPr/>
+        </p:nvSpPr>
+        <p:spPr>
+          <a:xfrm xmlns:a="http://schemas.openxmlformats.org/drawingml/2006/main">
+            <a:off x="10808208" y="182880"/>
+            <a:ext cx="914400" cy="310896"/>
+          </a:xfrm>
+          <a:prstGeom xmlns:a="http://schemas.openxmlformats.org/drawingml/2006/main" prst="roundRect">
+            <a:avLst/>
+          </a:prstGeom>
+          <a:solidFill xmlns:a="http://schemas.openxmlformats.org/drawingml/2006/main">
+            <a:srgbClr val="30515F"/>
+          </a:solidFill>
+          <a:ln xmlns:a="http://schemas.openxmlformats.org/drawingml/2006/main" w="12700">
+            <a:solidFill>
+              <a:srgbClr val="30515F"/>
+            </a:solidFill>
+          </a:ln>
+        </p:spPr>
+        <p:style>
+          <a:lnRef xmlns:a="http://schemas.openxmlformats.org/drawingml/2006/main" idx="1">
+            <a:schemeClr val="accent1"/>
+          </a:lnRef>
+          <a:fillRef xmlns:a="http://schemas.openxmlformats.org/drawingml/2006/main" idx="3">
+            <a:schemeClr val="accent1"/>
+          </a:fillRef>
+          <a:effectRef xmlns:a="http://schemas.openxmlformats.org/drawingml/2006/main" idx="2">
+            <a:schemeClr val="accent1"/>
+          </a:effectRef>
+          <a:fontRef xmlns:a="http://schemas.openxmlformats.org/drawingml/2006/main" idx="minor">
+            <a:schemeClr val="lt1"/>
+          </a:fontRef>
+        </p:style>
+        <p:txBody>
+          <a:bodyPr xmlns:a="http://schemas.openxmlformats.org/drawingml/2006/main" anchor="ctr"/>
+          <a:lstStyle xmlns:a="http://schemas.openxmlformats.org/drawingml/2006/main"/>
+          <a:p xmlns:a="http://schemas.openxmlformats.org/drawingml/2006/main">
+            <a:pPr algn="ctr">
+              <a:buNone/>
+            </a:pPr>
+            <a:endParaRPr/>
+          </a:p>
+        </p:txBody>
+      </p:sp>
+      <p:sp>
+        <p:nvSpPr>
+          <p:cNvPr id="5" name="ctt:page">
+            <a:extLst xmlns:a="http://schemas.openxmlformats.org/drawingml/2006/main">
+              <a:ext uri="{FF2B5EF4-FFF2-40B4-BE49-F238E27FC236}">
+                <a16:creationId xmlns:a16="http://schemas.microsoft.com/office/drawing/2014/main" id="{C48093AE-9A41-477B-83D6-2B0579BD2AC0}"/>
+              </a:ext>
+            </a:extLst>
+          </p:cNvPr>
+          <p:cNvSpPr>
+            <a:spLocks xmlns:a="http://schemas.openxmlformats.org/drawingml/2006/main" noGrp="1"/>
+          </p:cNvSpPr>
+          <p:nvPr/>
+        </p:nvSpPr>
+        <p:spPr>
+          <a:xfrm xmlns:a="http://schemas.openxmlformats.org/drawingml/2006/main">
+            <a:off x="10808208" y="182880"/>
+            <a:ext cx="914400" cy="310896"/>
+          </a:xfrm>
+          <a:prstGeom xmlns:a="http://schemas.openxmlformats.org/drawingml/2006/main" prst="rect">
+            <a:avLst/>
+          </a:prstGeom>
+          <a:noFill xmlns:a="http://schemas.openxmlformats.org/drawingml/2006/main"/>
+        </p:spPr>
+        <p:txBody>
+          <a:bodyPr xmlns:a="http://schemas.openxmlformats.org/drawingml/2006/main" wrap="none" lIns="0" tIns="0" rIns="0" bIns="0" anchor="ctr">
+            <a:spAutoFit/>
+          </a:bodyPr>
+          <a:lstStyle xmlns:a="http://schemas.openxmlformats.org/drawingml/2006/main"/>
+          <a:p xmlns:a="http://schemas.openxmlformats.org/drawingml/2006/main">
+            <a:pPr algn="ctr">
+              <a:buNone/>
+            </a:pPr>
+            <a:r>
+              <a:rPr sz="850" b="1">
+                <a:solidFill>
+                  <a:srgbClr val="FFFFFF"/>
+                </a:solidFill>
+                <a:latin typeface="Calibri"/>
+                <a:ea typeface="Calibri"/>
+                <a:cs typeface="Calibri"/>
+              </a:rPr>
+              <a:t>{{page}}</a:t>
+            </a:r>
+          </a:p>
+        </p:txBody>
+      </p:sp>
+      <p:sp>
+        <p:nvSpPr>
+          <p:cNvPr id="6" name="Rounded Rectangle 5">
+            <a:extLst xmlns:a="http://schemas.openxmlformats.org/drawingml/2006/main">
+              <a:ext uri="{FF2B5EF4-FFF2-40B4-BE49-F238E27FC236}">
+                <a16:creationId xmlns:a16="http://schemas.microsoft.com/office/drawing/2014/main" id="{F954B7BE-2779-45B1-877A-1BBBDD2EF231}"/>
+              </a:ext>
+            </a:extLst>
+          </p:cNvPr>
+          <p:cNvSpPr>
+            <a:spLocks xmlns:a="http://schemas.openxmlformats.org/drawingml/2006/main" noGrp="1"/>
+          </p:cNvSpPr>
+          <p:nvPr/>
+        </p:nvSpPr>
+        <p:spPr>
+          <a:xfrm xmlns:a="http://schemas.openxmlformats.org/drawingml/2006/main">
+            <a:off x="566928" y="932688"/>
+            <a:ext cx="365760" cy="274320"/>
+          </a:xfrm>
+          <a:prstGeom xmlns:a="http://schemas.openxmlformats.org/drawingml/2006/main" prst="roundRect">
+            <a:avLst/>
+          </a:prstGeom>
+          <a:solidFill xmlns:a="http://schemas.openxmlformats.org/drawingml/2006/main">
+            <a:srgbClr val="76B82A"/>
+          </a:solidFill>
+          <a:ln xmlns:a="http://schemas.openxmlformats.org/drawingml/2006/main" w="12700">
+            <a:solidFill>
+              <a:srgbClr val="76B82A"/>
+            </a:solidFill>
+          </a:ln>
+        </p:spPr>
+        <p:style>
+          <a:lnRef xmlns:a="http://schemas.openxmlformats.org/drawingml/2006/main" idx="1">
+            <a:schemeClr val="accent1"/>
+          </a:lnRef>
+          <a:fillRef xmlns:a="http://schemas.openxmlformats.org/drawingml/2006/main" idx="3">
+            <a:schemeClr val="accent1"/>
+          </a:fillRef>
+          <a:effectRef xmlns:a="http://schemas.openxmlformats.org/drawingml/2006/main" idx="2">
+            <a:schemeClr val="accent1"/>
+          </a:effectRef>
+          <a:fontRef xmlns:a="http://schemas.openxmlformats.org/drawingml/2006/main" idx="minor">
+            <a:schemeClr val="lt1"/>
+          </a:fontRef>
+        </p:style>
+        <p:txBody>
+          <a:bodyPr xmlns:a="http://schemas.openxmlformats.org/drawingml/2006/main" anchor="ctr"/>
+          <a:lstStyle xmlns:a="http://schemas.openxmlformats.org/drawingml/2006/main"/>
+          <a:p xmlns:a="http://schemas.openxmlformats.org/drawingml/2006/main">
+            <a:pPr algn="ctr">
+              <a:buNone/>
+            </a:pPr>
+            <a:endParaRPr/>
+          </a:p>
+        </p:txBody>
+      </p:sp>
+      <p:sp>
+        <p:nvSpPr>
+          <p:cNvPr id="7" name="TextBox 6">
+            <a:extLst xmlns:a="http://schemas.openxmlformats.org/drawingml/2006/main">
+              <a:ext uri="{FF2B5EF4-FFF2-40B4-BE49-F238E27FC236}">
+                <a16:creationId xmlns:a16="http://schemas.microsoft.com/office/drawing/2014/main" id="{AA2CDE9D-DF2C-491B-8907-6FF33DD842CF}"/>
+              </a:ext>
+            </a:extLst>
+          </p:cNvPr>
+          <p:cNvSpPr>
+            <a:spLocks xmlns:a="http://schemas.openxmlformats.org/drawingml/2006/main" noGrp="1"/>
+          </p:cNvSpPr>
+          <p:nvPr/>
+        </p:nvSpPr>
+        <p:spPr>
+          <a:xfrm xmlns:a="http://schemas.openxmlformats.org/drawingml/2006/main">
+            <a:off x="566928" y="932688"/>
+            <a:ext cx="365760" cy="274320"/>
+          </a:xfrm>
+          <a:prstGeom xmlns:a="http://schemas.openxmlformats.org/drawingml/2006/main" prst="rect">
+            <a:avLst/>
+          </a:prstGeom>
+          <a:noFill xmlns:a="http://schemas.openxmlformats.org/drawingml/2006/main"/>
+        </p:spPr>
+        <p:txBody>
+          <a:bodyPr xmlns:a="http://schemas.openxmlformats.org/drawingml/2006/main" wrap="none" lIns="0" tIns="0" rIns="0" bIns="0" anchor="ctr">
+            <a:spAutoFit/>
+          </a:bodyPr>
+          <a:lstStyle xmlns:a="http://schemas.openxmlformats.org/drawingml/2006/main"/>
+          <a:p xmlns:a="http://schemas.openxmlformats.org/drawingml/2006/main">
+            <a:pPr algn="ctr">
+              <a:buNone/>
+            </a:pPr>
+            <a:r>
+              <a:rPr sz="819" b="1">
+                <a:solidFill>
+                  <a:srgbClr val="FFFFFF"/>
+                </a:solidFill>
+                <a:latin typeface="Calibri"/>
+                <a:ea typeface="Calibri"/>
+                <a:cs typeface="Calibri"/>
+              </a:rPr>
+              <a:t>01</a:t>
+            </a:r>
+          </a:p>
+        </p:txBody>
+      </p:sp>
+      <p:sp>
+        <p:nvSpPr>
+          <p:cNvPr id="8" name="ctt:detail_left_label">
+            <a:extLst xmlns:a="http://schemas.openxmlformats.org/drawingml/2006/main">
+              <a:ext uri="{FF2B5EF4-FFF2-40B4-BE49-F238E27FC236}">
+                <a16:creationId xmlns:a16="http://schemas.microsoft.com/office/drawing/2014/main" id="{4769D5F4-094A-4582-8488-BEB14072BC23}"/>
+              </a:ext>
+            </a:extLst>
+          </p:cNvPr>
+          <p:cNvSpPr>
+            <a:spLocks xmlns:a="http://schemas.openxmlformats.org/drawingml/2006/main" noGrp="1"/>
+          </p:cNvSpPr>
+          <p:nvPr/>
+        </p:nvSpPr>
+        <p:spPr>
+          <a:xfrm xmlns:a="http://schemas.openxmlformats.org/drawingml/2006/main">
+            <a:off x="1051560" y="923544"/>
+            <a:ext cx="10572750" cy="292608"/>
+          </a:xfrm>
+          <a:prstGeom xmlns:a="http://schemas.openxmlformats.org/drawingml/2006/main" prst="rect">
+            <a:avLst/>
+          </a:prstGeom>
+          <a:noFill xmlns:a="http://schemas.openxmlformats.org/drawingml/2006/main"/>
+        </p:spPr>
+        <p:txBody>
+          <a:bodyPr xmlns:a="http://schemas.openxmlformats.org/drawingml/2006/main" wrap="none" lIns="0" tIns="0" rIns="0" bIns="0" anchor="ctr">
+            <a:spAutoFit/>
+          </a:bodyPr>
+          <a:lstStyle xmlns:a="http://schemas.openxmlformats.org/drawingml/2006/main"/>
+          <a:p xmlns:a="http://schemas.openxmlformats.org/drawingml/2006/main">
+            <a:pPr algn="l">
+              <a:buNone/>
+            </a:pPr>
+            <a:r>
+              <a:rPr sz="1060" b="1">
+                <a:solidFill>
+                  <a:srgbClr val="30515F"/>
+                </a:solidFill>
+                <a:latin typeface="Calibri"/>
+                <a:ea typeface="Calibri"/>
+                <a:cs typeface="Calibri"/>
+              </a:rPr>
+              <a:t>{{detail_left_label}}</a:t>
+            </a:r>
+          </a:p>
+        </p:txBody>
+      </p:sp>
+      <p:sp>
+        <p:nvSpPr>
+          <p:cNvPr id="12" name="Rectangle 11">
+            <a:extLst xmlns:a="http://schemas.openxmlformats.org/drawingml/2006/main">
+              <a:ext uri="{FF2B5EF4-FFF2-40B4-BE49-F238E27FC236}">
+                <a16:creationId xmlns:a16="http://schemas.microsoft.com/office/drawing/2014/main" id="{7DF3B780-F536-4EDD-9B54-FCE4EC7C7595}"/>
+              </a:ext>
+            </a:extLst>
+          </p:cNvPr>
+          <p:cNvSpPr>
+            <a:spLocks xmlns:a="http://schemas.openxmlformats.org/drawingml/2006/main" noGrp="1"/>
+          </p:cNvSpPr>
+          <p:nvPr/>
+        </p:nvSpPr>
+        <p:spPr>
+          <a:xfrm xmlns:a="http://schemas.openxmlformats.org/drawingml/2006/main">
+            <a:off x="539496" y="1316736"/>
+            <a:ext cx="11128248" cy="3493008"/>
+          </a:xfrm>
+          <a:prstGeom xmlns:a="http://schemas.openxmlformats.org/drawingml/2006/main" prst="rect">
+            <a:avLst/>
+          </a:prstGeom>
+          <a:solidFill xmlns:a="http://schemas.openxmlformats.org/drawingml/2006/main">
+            <a:srgbClr val="FFFFFF"/>
+          </a:solidFill>
+          <a:ln xmlns:a="http://schemas.openxmlformats.org/drawingml/2006/main" w="12700">
+            <a:solidFill>
+              <a:srgbClr val="CDD8D2"/>
+            </a:solidFill>
+          </a:ln>
+        </p:spPr>
+        <p:style>
+          <a:lnRef xmlns:a="http://schemas.openxmlformats.org/drawingml/2006/main" idx="1">
+            <a:schemeClr val="accent1"/>
+          </a:lnRef>
+          <a:fillRef xmlns:a="http://schemas.openxmlformats.org/drawingml/2006/main" idx="3">
+            <a:schemeClr val="accent1"/>
+          </a:fillRef>
+          <a:effectRef xmlns:a="http://schemas.openxmlformats.org/drawingml/2006/main" idx="2">
+            <a:schemeClr val="accent1"/>
+          </a:effectRef>
+          <a:fontRef xmlns:a="http://schemas.openxmlformats.org/drawingml/2006/main" idx="minor">
+            <a:schemeClr val="lt1"/>
+          </a:fontRef>
+        </p:style>
+        <p:txBody>
+          <a:bodyPr xmlns:a="http://schemas.openxmlformats.org/drawingml/2006/main" anchor="ctr"/>
+          <a:lstStyle xmlns:a="http://schemas.openxmlformats.org/drawingml/2006/main"/>
+          <a:p xmlns:a="http://schemas.openxmlformats.org/drawingml/2006/main">
+            <a:pPr algn="ctr">
+              <a:buNone/>
+            </a:pPr>
+            <a:endParaRPr/>
+          </a:p>
+        </p:txBody>
+      </p:sp>
+      <p:sp>
+        <p:nvSpPr>
+          <p:cNvPr id="16" name="Rounded Rectangle 15">
+            <a:extLst xmlns:a="http://schemas.openxmlformats.org/drawingml/2006/main">
+              <a:ext uri="{FF2B5EF4-FFF2-40B4-BE49-F238E27FC236}">
+                <a16:creationId xmlns:a16="http://schemas.microsoft.com/office/drawing/2014/main" id="{41A47DC6-D056-4DB5-9BEB-3C7AED3ACBEA}"/>
+              </a:ext>
+            </a:extLst>
+          </p:cNvPr>
+          <p:cNvSpPr>
+            <a:spLocks xmlns:a="http://schemas.openxmlformats.org/drawingml/2006/main" noGrp="1"/>
+          </p:cNvSpPr>
+          <p:nvPr/>
+        </p:nvSpPr>
+        <p:spPr>
+          <a:xfrm xmlns:a="http://schemas.openxmlformats.org/drawingml/2006/main">
+            <a:off x="566928" y="5056632"/>
+            <a:ext cx="11073384" cy="475488"/>
+          </a:xfrm>
+          <a:prstGeom xmlns:a="http://schemas.openxmlformats.org/drawingml/2006/main" prst="roundRect">
+            <a:avLst/>
+          </a:prstGeom>
+          <a:solidFill xmlns:a="http://schemas.openxmlformats.org/drawingml/2006/main">
+            <a:srgbClr val="EDF5E4"/>
+          </a:solidFill>
+          <a:ln xmlns:a="http://schemas.openxmlformats.org/drawingml/2006/main" w="12700">
+            <a:solidFill>
+              <a:srgbClr val="D9E7CF"/>
+            </a:solidFill>
+          </a:ln>
+        </p:spPr>
+        <p:style>
+          <a:lnRef xmlns:a="http://schemas.openxmlformats.org/drawingml/2006/main" idx="1">
+            <a:schemeClr val="accent1"/>
+          </a:lnRef>
+          <a:fillRef xmlns:a="http://schemas.openxmlformats.org/drawingml/2006/main" idx="3">
+            <a:schemeClr val="accent1"/>
+          </a:fillRef>
+          <a:effectRef xmlns:a="http://schemas.openxmlformats.org/drawingml/2006/main" idx="2">
+            <a:schemeClr val="accent1"/>
+          </a:effectRef>
+          <a:fontRef xmlns:a="http://schemas.openxmlformats.org/drawingml/2006/main" idx="minor">
+            <a:schemeClr val="lt1"/>
+          </a:fontRef>
+        </p:style>
+        <p:txBody>
+          <a:bodyPr xmlns:a="http://schemas.openxmlformats.org/drawingml/2006/main" anchor="ctr"/>
+          <a:lstStyle xmlns:a="http://schemas.openxmlformats.org/drawingml/2006/main"/>
+          <a:p xmlns:a="http://schemas.openxmlformats.org/drawingml/2006/main">
+            <a:pPr algn="ctr">
+              <a:buNone/>
+            </a:pPr>
+            <a:endParaRPr/>
+          </a:p>
+        </p:txBody>
+      </p:sp>
+      <p:sp>
+        <p:nvSpPr>
+          <p:cNvPr id="17" name="Rectangle 16">
+            <a:extLst xmlns:a="http://schemas.openxmlformats.org/drawingml/2006/main">
+              <a:ext uri="{FF2B5EF4-FFF2-40B4-BE49-F238E27FC236}">
+                <a16:creationId xmlns:a16="http://schemas.microsoft.com/office/drawing/2014/main" id="{7EF9DB36-E0CC-45C9-859E-EBB74552D538}"/>
+              </a:ext>
+            </a:extLst>
+          </p:cNvPr>
+          <p:cNvSpPr>
+            <a:spLocks xmlns:a="http://schemas.openxmlformats.org/drawingml/2006/main" noGrp="1"/>
+          </p:cNvSpPr>
+          <p:nvPr/>
+        </p:nvSpPr>
+        <p:spPr>
+          <a:xfrm xmlns:a="http://schemas.openxmlformats.org/drawingml/2006/main">
+            <a:off x="676656" y="5166360"/>
+            <a:ext cx="45720" cy="256032"/>
+          </a:xfrm>
+          <a:prstGeom xmlns:a="http://schemas.openxmlformats.org/drawingml/2006/main" prst="rect">
+            <a:avLst/>
+          </a:prstGeom>
+          <a:solidFill xmlns:a="http://schemas.openxmlformats.org/drawingml/2006/main">
+            <a:srgbClr val="76B82A"/>
+          </a:solidFill>
+          <a:ln xmlns:a="http://schemas.openxmlformats.org/drawingml/2006/main" w="12700">
+            <a:solidFill>
+              <a:srgbClr val="76B82A"/>
+            </a:solidFill>
+          </a:ln>
+        </p:spPr>
+        <p:style>
+          <a:lnRef xmlns:a="http://schemas.openxmlformats.org/drawingml/2006/main" idx="1">
+            <a:schemeClr val="accent1"/>
+          </a:lnRef>
+          <a:fillRef xmlns:a="http://schemas.openxmlformats.org/drawingml/2006/main" idx="3">
+            <a:schemeClr val="accent1"/>
+          </a:fillRef>
+          <a:effectRef xmlns:a="http://schemas.openxmlformats.org/drawingml/2006/main" idx="2">
+            <a:schemeClr val="accent1"/>
+          </a:effectRef>
+          <a:fontRef xmlns:a="http://schemas.openxmlformats.org/drawingml/2006/main" idx="minor">
+            <a:schemeClr val="lt1"/>
+          </a:fontRef>
+        </p:style>
+        <p:txBody>
+          <a:bodyPr xmlns:a="http://schemas.openxmlformats.org/drawingml/2006/main" anchor="ctr"/>
+          <a:lstStyle xmlns:a="http://schemas.openxmlformats.org/drawingml/2006/main"/>
+          <a:p xmlns:a="http://schemas.openxmlformats.org/drawingml/2006/main">
+            <a:pPr algn="ctr">
+              <a:buNone/>
+            </a:pPr>
+            <a:endParaRPr/>
+          </a:p>
+        </p:txBody>
+      </p:sp>
+      <p:sp>
+        <p:nvSpPr>
+          <p:cNvPr id="18" name="ctt:detail_left_caption">
+            <a:extLst xmlns:a="http://schemas.openxmlformats.org/drawingml/2006/main">
+              <a:ext uri="{FF2B5EF4-FFF2-40B4-BE49-F238E27FC236}">
+                <a16:creationId xmlns:a16="http://schemas.microsoft.com/office/drawing/2014/main" id="{86D3A68E-60AA-46B3-8064-3918FAD9C6EB}"/>
+              </a:ext>
+            </a:extLst>
+          </p:cNvPr>
+          <p:cNvSpPr>
+            <a:spLocks xmlns:a="http://schemas.openxmlformats.org/drawingml/2006/main" noGrp="1"/>
+          </p:cNvSpPr>
+          <p:nvPr/>
+        </p:nvSpPr>
+        <p:spPr>
+          <a:xfrm xmlns:a="http://schemas.openxmlformats.org/drawingml/2006/main">
+            <a:off x="822960" y="5102352"/>
+            <a:ext cx="10668000" cy="384048"/>
+          </a:xfrm>
+          <a:prstGeom xmlns:a="http://schemas.openxmlformats.org/drawingml/2006/main" prst="rect">
+            <a:avLst/>
+          </a:prstGeom>
+          <a:noFill xmlns:a="http://schemas.openxmlformats.org/drawingml/2006/main"/>
+        </p:spPr>
+        <p:txBody>
+          <a:bodyPr xmlns:a="http://schemas.openxmlformats.org/drawingml/2006/main" wrap="none" lIns="0" tIns="0" rIns="0" bIns="0" anchor="ctr">
+            <a:spAutoFit/>
+          </a:bodyPr>
+          <a:lstStyle xmlns:a="http://schemas.openxmlformats.org/drawingml/2006/main"/>
+          <a:p xmlns:a="http://schemas.openxmlformats.org/drawingml/2006/main">
+            <a:pPr algn="l">
+              <a:buNone/>
+            </a:pPr>
+            <a:r>
+              <a:rPr sz="919" b="1">
+                <a:solidFill>
+                  <a:srgbClr val="30515F"/>
+                </a:solidFill>
+                <a:latin typeface="Calibri"/>
+                <a:ea typeface="Calibri"/>
+                <a:cs typeface="Calibri"/>
+              </a:rPr>
+              <a:t>{{detail_left_caption}}</a:t>
+            </a:r>
+          </a:p>
+        </p:txBody>
+      </p:sp>
+      <p:sp>
+        <p:nvSpPr>
+          <p:cNvPr id="22" name="Rectangle 21">
+            <a:extLst xmlns:a="http://schemas.openxmlformats.org/drawingml/2006/main">
+              <a:ext uri="{FF2B5EF4-FFF2-40B4-BE49-F238E27FC236}">
+                <a16:creationId xmlns:a16="http://schemas.microsoft.com/office/drawing/2014/main" id="{507288E7-2F3D-4512-8E9F-4F1FD7F1AD27}"/>
+              </a:ext>
+            </a:extLst>
+          </p:cNvPr>
+          <p:cNvSpPr>
+            <a:spLocks xmlns:a="http://schemas.openxmlformats.org/drawingml/2006/main" noGrp="1"/>
+          </p:cNvSpPr>
+          <p:nvPr/>
+        </p:nvSpPr>
+        <p:spPr>
+          <a:xfrm xmlns:a="http://schemas.openxmlformats.org/drawingml/2006/main">
+            <a:off x="566928" y="5788152"/>
+            <a:ext cx="11073384" cy="18288"/>
+          </a:xfrm>
+          <a:prstGeom xmlns:a="http://schemas.openxmlformats.org/drawingml/2006/main" prst="rect">
+            <a:avLst/>
+          </a:prstGeom>
+          <a:solidFill xmlns:a="http://schemas.openxmlformats.org/drawingml/2006/main">
+            <a:srgbClr val="DCE5E0"/>
+          </a:solidFill>
+          <a:ln xmlns:a="http://schemas.openxmlformats.org/drawingml/2006/main" w="12700">
+            <a:solidFill>
+              <a:srgbClr val="DCE5E0"/>
+            </a:solidFill>
+          </a:ln>
+        </p:spPr>
+        <p:style>
+          <a:lnRef xmlns:a="http://schemas.openxmlformats.org/drawingml/2006/main" idx="1">
+            <a:schemeClr val="accent1"/>
+          </a:lnRef>
+          <a:fillRef xmlns:a="http://schemas.openxmlformats.org/drawingml/2006/main" idx="3">
+            <a:schemeClr val="accent1"/>
+          </a:fillRef>
+          <a:effectRef xmlns:a="http://schemas.openxmlformats.org/drawingml/2006/main" idx="2">
+            <a:schemeClr val="accent1"/>
+          </a:effectRef>
+          <a:fontRef xmlns:a="http://schemas.openxmlformats.org/drawingml/2006/main" idx="minor">
+            <a:schemeClr val="lt1"/>
+          </a:fontRef>
+        </p:style>
+        <p:txBody>
+          <a:bodyPr xmlns:a="http://schemas.openxmlformats.org/drawingml/2006/main" anchor="ctr"/>
+          <a:lstStyle xmlns:a="http://schemas.openxmlformats.org/drawingml/2006/main"/>
+          <a:p xmlns:a="http://schemas.openxmlformats.org/drawingml/2006/main">
+            <a:pPr algn="ctr">
+              <a:buNone/>
+            </a:pPr>
+            <a:endParaRPr/>
+          </a:p>
+        </p:txBody>
+      </p:sp>
+      <p:sp>
+        <p:nvSpPr>
+          <p:cNvPr id="23" name="ctt:footer">
+            <a:extLst xmlns:a="http://schemas.openxmlformats.org/drawingml/2006/main">
+              <a:ext uri="{FF2B5EF4-FFF2-40B4-BE49-F238E27FC236}">
+                <a16:creationId xmlns:a16="http://schemas.microsoft.com/office/drawing/2014/main" id="{ECECD2E3-FF06-4895-B6B5-45F8788D9985}"/>
+              </a:ext>
+            </a:extLst>
+          </p:cNvPr>
+          <p:cNvSpPr>
+            <a:spLocks xmlns:a="http://schemas.openxmlformats.org/drawingml/2006/main" noGrp="1"/>
+          </p:cNvSpPr>
+          <p:nvPr/>
+        </p:nvSpPr>
+        <p:spPr>
+          <a:xfrm xmlns:a="http://schemas.openxmlformats.org/drawingml/2006/main">
+            <a:off x="457200" y="6446520"/>
+            <a:ext cx="3017520" cy="182880"/>
+          </a:xfrm>
+          <a:prstGeom xmlns:a="http://schemas.openxmlformats.org/drawingml/2006/main" prst="rect">
+            <a:avLst/>
+          </a:prstGeom>
+          <a:noFill xmlns:a="http://schemas.openxmlformats.org/drawingml/2006/main"/>
+        </p:spPr>
+        <p:txBody>
+          <a:bodyPr xmlns:a="http://schemas.openxmlformats.org/drawingml/2006/main" wrap="none" lIns="0" tIns="0" rIns="0" bIns="0" anchor="ctr">
+            <a:spAutoFit/>
+          </a:bodyPr>
+          <a:lstStyle xmlns:a="http://schemas.openxmlformats.org/drawingml/2006/main"/>
+          <a:p xmlns:a="http://schemas.openxmlformats.org/drawingml/2006/main">
+            <a:pPr algn="l">
+              <a:buNone/>
+            </a:pPr>
+            <a:r>
+              <a:rPr sz="740" b="1">
+                <a:solidFill>
+                  <a:srgbClr val="7F7F7F"/>
+                </a:solidFill>
+                <a:latin typeface="Calibri"/>
+                <a:ea typeface="Calibri"/>
+                <a:cs typeface="Calibri"/>
+              </a:rPr>
+              <a:t>{{footer}}</a:t>
+            </a:r>
+          </a:p>
+        </p:txBody>
+      </p:sp>
+      <p:sp>
+        <p:nvSpPr>
+          <p:cNvPr id="25" name="ctt:detail_left">
+            <a:extLst xmlns:a="http://schemas.openxmlformats.org/drawingml/2006/main">
+              <a:ext uri="{FF2B5EF4-FFF2-40B4-BE49-F238E27FC236}">
+                <a16:creationId xmlns:a16="http://schemas.microsoft.com/office/drawing/2014/main" id="{CC290EB3-4D3C-4540-8535-B2686939E186}"/>
+              </a:ext>
+            </a:extLst>
+          </p:cNvPr>
+          <p:cNvSpPr>
+            <a:spLocks xmlns:a="http://schemas.openxmlformats.org/drawingml/2006/main" noGrp="1"/>
+          </p:cNvSpPr>
+          <p:nvPr/>
+        </p:nvSpPr>
+        <p:spPr>
+          <a:xfrm xmlns:a="http://schemas.openxmlformats.org/drawingml/2006/main">
+            <a:off x="714375" y="1476375"/>
+            <a:ext cx="10763250" cy="3238500"/>
+          </a:xfrm>
+          <a:prstGeom xmlns:a="http://schemas.openxmlformats.org/drawingml/2006/main" prst="rect">
+            <a:avLst/>
+          </a:prstGeom>
+          <a:noFill xmlns:a="http://schemas.openxmlformats.org/drawingml/2006/main"/>
+          <a:ln xmlns:a="http://schemas.openxmlformats.org/drawingml/2006/main" w="0">
+            <a:noFill/>
+          </a:ln>
+        </p:spPr>
+        <p:txBody>
+          <a:bodyPr xmlns:a="http://schemas.openxmlformats.org/drawingml/2006/main">
+            <a:noAutofit/>
+          </a:bodyPr>
+          <a:lstStyle xmlns:a="http://schemas.openxmlformats.org/drawingml/2006/main"/>
+          <a:p xmlns:a="http://schemas.openxmlformats.org/drawingml/2006/main">
+            <a:pPr algn="l">
+              <a:buNone/>
+              <a:defRPr sz="1800" b="0">
+                <a:solidFill>
+                  <a:srgbClr val="30515F"/>
+                </a:solidFill>
+                <a:latin typeface="Calibri"/>
+                <a:ea typeface="Calibri"/>
+                <a:cs typeface="Calibri"/>
+              </a:defRPr>
+            </a:pPr>
+            <a:r>
+              <a:rPr sz="1800" b="0">
+                <a:solidFill>
+                  <a:srgbClr val="30515F"/>
+                </a:solidFill>
+                <a:latin typeface="Calibri"/>
+                <a:ea typeface="Calibri"/>
+                <a:cs typeface="Calibri"/>
+              </a:rPr>
+              <a:t>{{detail_left}}</a:t>
+            </a:r>
+          </a:p>
+        </p:txBody>
+      </p:sp>
+    </p:spTree>
+    <p:extLst>
+      <p:ext uri="{BB962C8B-B14F-4D97-AF65-F5344CB8AC3E}">
+        <p14:creationId xmlns:p14="http://schemas.microsoft.com/office/powerpoint/2010/main" val="1896818118"/>
+      </p:ext>
+    </p:extLst>
+  </p:cSld>
+</p:sld>
+</file>
+
+<file path=ppt/slides/slide13.xml><?xml version="1.0" encoding="utf-8"?>
+<p:sld xmlns:p="http://schemas.openxmlformats.org/presentationml/2006/main">
+  <p:cSld>
+    <p:spTree>
+      <p:nvGrpSpPr>
+        <p:cNvPr id="1" name=""/>
+        <p:cNvGrpSpPr/>
+        <p:nvPr/>
+      </p:nvGrpSpPr>
+      <p:grpSpPr>
+        <a:xfrm xmlns:a="http://schemas.openxmlformats.org/drawingml/2006/main"/>
+      </p:grpSpPr>
+      <p:pic>
+        <p:nvPicPr>
+          <p:cNvPr id="39" name="Picture 1"/>
+          <p:cNvPicPr>
+            <a:picLocks xmlns:a="http://schemas.openxmlformats.org/drawingml/2006/main" noChangeAspect="1"/>
+          </p:cNvPicPr>
+          <p:nvPr/>
+        </p:nvPicPr>
+        <p:blipFill>
+          <a:blip xmlns:r="http://schemas.openxmlformats.org/officeDocument/2006/relationships" xmlns:a="http://schemas.openxmlformats.org/drawingml/2006/main" r:embed="R6621792166c54150"/>
+          <a:stretch xmlns:a="http://schemas.openxmlformats.org/drawingml/2006/main">
+            <a:fillRect l="0" t="0" r="0" b="0"/>
+          </a:stretch>
+        </p:blipFill>
+        <p:spPr>
+          <a:xfrm xmlns:a="http://schemas.openxmlformats.org/drawingml/2006/main">
+            <a:off x="0" y="0"/>
+            <a:ext cx="12192000" cy="6858000"/>
+          </a:xfrm>
+          <a:prstGeom xmlns:a="http://schemas.openxmlformats.org/drawingml/2006/main" prst="rect">
+            <a:avLst/>
+          </a:prstGeom>
+        </p:spPr>
+      </p:pic>
+      <p:sp>
+        <p:nvSpPr>
+          <p:cNvPr id="23" name="ctt:summary_title">
+            <a:extLst xmlns:a="http://schemas.openxmlformats.org/drawingml/2006/main">
+              <a:ext uri="{FF2B5EF4-FFF2-40B4-BE49-F238E27FC236}">
+                <a16:creationId xmlns:a16="http://schemas.microsoft.com/office/drawing/2014/main" id="{375409D4-B7C1-47AC-B560-DB3ACC7D1FE2}"/>
+              </a:ext>
+            </a:extLst>
+          </p:cNvPr>
+          <p:cNvSpPr>
+            <a:spLocks xmlns:a="http://schemas.openxmlformats.org/drawingml/2006/main" noGrp="1"/>
+          </p:cNvSpPr>
+          <p:nvPr/>
+        </p:nvSpPr>
+        <p:spPr>
+          <a:xfrm xmlns:a="http://schemas.openxmlformats.org/drawingml/2006/main">
+            <a:off x="457200" y="109538"/>
+            <a:ext cx="10096500" cy="485775"/>
+          </a:xfrm>
+          <a:prstGeom xmlns:a="http://schemas.openxmlformats.org/drawingml/2006/main" prst="rect">
+            <a:avLst/>
+          </a:prstGeom>
+          <a:noFill xmlns:a="http://schemas.openxmlformats.org/drawingml/2006/main"/>
+          <a:ln xmlns:a="http://schemas.openxmlformats.org/drawingml/2006/main" w="0">
+            <a:noFill/>
+          </a:ln>
+        </p:spPr>
+        <p:txBody>
+          <a:bodyPr xmlns:a="http://schemas.openxmlformats.org/drawingml/2006/main">
+            <a:noAutofit/>
+          </a:bodyPr>
+          <a:lstStyle xmlns:a="http://schemas.openxmlformats.org/drawingml/2006/main"/>
+          <a:p xmlns:a="http://schemas.openxmlformats.org/drawingml/2006/main">
+            <a:pPr algn="l">
+              <a:buNone/>
+              <a:defRPr sz="2400" b="1">
+                <a:solidFill>
+                  <a:srgbClr val="76B82A"/>
+                </a:solidFill>
+                <a:latin typeface="Calibri"/>
+                <a:ea typeface="Calibri"/>
+                <a:cs typeface="Calibri"/>
+              </a:defRPr>
+            </a:pPr>
+            <a:r>
+              <a:rPr sz="2400" b="1">
+                <a:solidFill>
+                  <a:srgbClr val="76B82A"/>
+                </a:solidFill>
+                <a:latin typeface="Calibri"/>
+                <a:ea typeface="Calibri"/>
+                <a:cs typeface="Calibri"/>
+              </a:rPr>
+              <a:t>{{summary_title}}</a:t>
+            </a:r>
+          </a:p>
+        </p:txBody>
+      </p:sp>
+      <p:sp>
+        <p:nvSpPr>
+          <p:cNvPr id="24" name="ctt:page">
+            <a:extLst xmlns:a="http://schemas.openxmlformats.org/drawingml/2006/main">
+              <a:ext uri="{FF2B5EF4-FFF2-40B4-BE49-F238E27FC236}">
+                <a16:creationId xmlns:a16="http://schemas.microsoft.com/office/drawing/2014/main" id="{FE2383C1-2805-4CBE-AB52-AC04603F3073}"/>
+              </a:ext>
+            </a:extLst>
+          </p:cNvPr>
+          <p:cNvSpPr>
+            <a:spLocks xmlns:a="http://schemas.openxmlformats.org/drawingml/2006/main" noGrp="1"/>
+          </p:cNvSpPr>
+          <p:nvPr/>
+        </p:nvSpPr>
+        <p:spPr>
+          <a:xfrm xmlns:a="http://schemas.openxmlformats.org/drawingml/2006/main">
+            <a:off x="10801350" y="209550"/>
+            <a:ext cx="914400" cy="285750"/>
+          </a:xfrm>
+          <a:prstGeom xmlns:a="http://schemas.openxmlformats.org/drawingml/2006/main" prst="rect">
+            <a:avLst/>
+          </a:prstGeom>
+          <a:noFill xmlns:a="http://schemas.openxmlformats.org/drawingml/2006/main"/>
+          <a:ln xmlns:a="http://schemas.openxmlformats.org/drawingml/2006/main" w="0">
+            <a:noFill/>
+          </a:ln>
+        </p:spPr>
+        <p:txBody>
+          <a:bodyPr xmlns:a="http://schemas.openxmlformats.org/drawingml/2006/main">
+            <a:noAutofit/>
+          </a:bodyPr>
+          <a:lstStyle xmlns:a="http://schemas.openxmlformats.org/drawingml/2006/main"/>
+          <a:p xmlns:a="http://schemas.openxmlformats.org/drawingml/2006/main">
+            <a:pPr algn="ctr">
+              <a:buNone/>
+              <a:defRPr sz="975" b="1">
+                <a:solidFill>
+                  <a:srgbClr val="30515F"/>
+                </a:solidFill>
+                <a:latin typeface="Calibri"/>
+                <a:ea typeface="Calibri"/>
+                <a:cs typeface="Calibri"/>
+              </a:defRPr>
+            </a:pPr>
+            <a:r>
+              <a:rPr sz="975" b="1">
+                <a:solidFill>
+                  <a:srgbClr val="30515F"/>
+                </a:solidFill>
+                <a:latin typeface="Calibri"/>
+                <a:ea typeface="Calibri"/>
+                <a:cs typeface="Calibri"/>
+              </a:rPr>
+              <a:t>{{page}}</a:t>
+            </a:r>
+          </a:p>
+        </p:txBody>
+      </p:sp>
+      <p:sp>
+        <p:nvSpPr>
+          <p:cNvPr id="26" name="ctt:footer">
+            <a:extLst xmlns:a="http://schemas.openxmlformats.org/drawingml/2006/main">
+              <a:ext uri="{FF2B5EF4-FFF2-40B4-BE49-F238E27FC236}">
+                <a16:creationId xmlns:a16="http://schemas.microsoft.com/office/drawing/2014/main" id="{1EAC3EBC-35B7-47AC-A281-700C5E20CAD4}"/>
+              </a:ext>
+            </a:extLst>
+          </p:cNvPr>
+          <p:cNvSpPr>
+            <a:spLocks xmlns:a="http://schemas.openxmlformats.org/drawingml/2006/main" noGrp="1"/>
+          </p:cNvSpPr>
+          <p:nvPr/>
+        </p:nvSpPr>
+        <p:spPr>
+          <a:xfrm xmlns:a="http://schemas.openxmlformats.org/drawingml/2006/main">
+            <a:off x="457200" y="6362700"/>
+            <a:ext cx="10001250" cy="238125"/>
+          </a:xfrm>
+          <a:prstGeom xmlns:a="http://schemas.openxmlformats.org/drawingml/2006/main" prst="rect">
+            <a:avLst/>
+          </a:prstGeom>
+          <a:noFill xmlns:a="http://schemas.openxmlformats.org/drawingml/2006/main"/>
+          <a:ln xmlns:a="http://schemas.openxmlformats.org/drawingml/2006/main" w="0">
+            <a:noFill/>
+          </a:ln>
+        </p:spPr>
+        <p:txBody>
+          <a:bodyPr xmlns:a="http://schemas.openxmlformats.org/drawingml/2006/main">
+            <a:noAutofit/>
+          </a:bodyPr>
+          <a:lstStyle xmlns:a="http://schemas.openxmlformats.org/drawingml/2006/main"/>
+          <a:p xmlns:a="http://schemas.openxmlformats.org/drawingml/2006/main">
+            <a:pPr algn="l">
+              <a:buNone/>
+              <a:defRPr sz="900" b="0">
+                <a:solidFill>
+                  <a:srgbClr val="7F7F7F"/>
+                </a:solidFill>
+                <a:latin typeface="Calibri"/>
+                <a:ea typeface="Calibri"/>
+                <a:cs typeface="Calibri"/>
+              </a:defRPr>
+            </a:pPr>
+            <a:r>
+              <a:rPr sz="900" b="0">
+                <a:solidFill>
+                  <a:srgbClr val="7F7F7F"/>
+                </a:solidFill>
+                <a:latin typeface="Calibri"/>
+                <a:ea typeface="Calibri"/>
+                <a:cs typeface="Calibri"/>
+              </a:rPr>
+              <a:t>{{footer}}</a:t>
+            </a:r>
+          </a:p>
+        </p:txBody>
+      </p:sp>
+      <p:sp>
+        <p:nvSpPr>
+          <p:cNvPr id="28" name="ctt:trace_context">
+            <a:extLst xmlns:a="http://schemas.openxmlformats.org/drawingml/2006/main">
+              <a:ext uri="{FF2B5EF4-FFF2-40B4-BE49-F238E27FC236}">
+                <a16:creationId xmlns:a16="http://schemas.microsoft.com/office/drawing/2014/main" id="{D0B6C3A2-BB94-48BD-ABC3-F1CF4DBEADF4}"/>
+              </a:ext>
+            </a:extLst>
+          </p:cNvPr>
+          <p:cNvSpPr>
+            <a:spLocks xmlns:a="http://schemas.openxmlformats.org/drawingml/2006/main" noGrp="1"/>
+          </p:cNvSpPr>
+          <p:nvPr/>
+        </p:nvSpPr>
+        <p:spPr>
+          <a:xfrm xmlns:a="http://schemas.openxmlformats.org/drawingml/2006/main">
+            <a:off x="571500" y="933450"/>
+            <a:ext cx="11001375" cy="666750"/>
+          </a:xfrm>
+          <a:prstGeom xmlns:a="http://schemas.openxmlformats.org/drawingml/2006/main" prst="rect">
+            <a:avLst/>
+          </a:prstGeom>
+          <a:noFill xmlns:a="http://schemas.openxmlformats.org/drawingml/2006/main"/>
+          <a:ln xmlns:a="http://schemas.openxmlformats.org/drawingml/2006/main" w="0">
+            <a:noFill/>
+          </a:ln>
+        </p:spPr>
+        <p:txBody>
+          <a:bodyPr xmlns:a="http://schemas.openxmlformats.org/drawingml/2006/main">
+            <a:noAutofit/>
+          </a:bodyPr>
+          <a:lstStyle xmlns:a="http://schemas.openxmlformats.org/drawingml/2006/main"/>
+          <a:p xmlns:a="http://schemas.openxmlformats.org/drawingml/2006/main">
+            <a:pPr>
+              <a:buNone/>
+              <a:defRPr sz="1800">
+                <a:solidFill>
+                  <a:srgbClr val="30515F"/>
+                </a:solidFill>
+                <a:latin typeface="Calibri"/>
+                <a:ea typeface="Calibri"/>
+                <a:cs typeface="Calibri"/>
+              </a:defRPr>
+            </a:pPr>
+            <a:r>
+              <a:rPr sz="1800">
+                <a:solidFill>
+                  <a:srgbClr val="30515F"/>
+                </a:solidFill>
+                <a:latin typeface="Calibri"/>
+                <a:ea typeface="Calibri"/>
+                <a:cs typeface="Calibri"/>
+              </a:rPr>
+              <a:t>{{trace_context}}</a:t>
+            </a:r>
+          </a:p>
+        </p:txBody>
+      </p:sp>
+      <p:sp>
+        <p:nvSpPr>
+          <p:cNvPr id="30" name="ctt:trace_caption">
+            <a:extLst xmlns:a="http://schemas.openxmlformats.org/drawingml/2006/main">
+              <a:ext uri="{FF2B5EF4-FFF2-40B4-BE49-F238E27FC236}">
+                <a16:creationId xmlns:a16="http://schemas.microsoft.com/office/drawing/2014/main" id="{996BC03A-2139-4EE6-A6DA-86DBD1B5914C}"/>
+              </a:ext>
+            </a:extLst>
+          </p:cNvPr>
+          <p:cNvSpPr>
+            <a:spLocks xmlns:a="http://schemas.openxmlformats.org/drawingml/2006/main" noGrp="1"/>
+          </p:cNvSpPr>
+          <p:nvPr/>
+        </p:nvSpPr>
+        <p:spPr>
+          <a:xfrm xmlns:a="http://schemas.openxmlformats.org/drawingml/2006/main">
+            <a:off x="571500" y="5762625"/>
+            <a:ext cx="11001375" cy="400050"/>
+          </a:xfrm>
+          <a:prstGeom xmlns:a="http://schemas.openxmlformats.org/drawingml/2006/main" prst="rect">
+            <a:avLst/>
+          </a:prstGeom>
+          <a:noFill xmlns:a="http://schemas.openxmlformats.org/drawingml/2006/main"/>
+          <a:ln xmlns:a="http://schemas.openxmlformats.org/drawingml/2006/main" w="0">
+            <a:noFill/>
+          </a:ln>
+        </p:spPr>
+        <p:txBody>
+          <a:bodyPr xmlns:a="http://schemas.openxmlformats.org/drawingml/2006/main">
+            <a:noAutofit/>
+          </a:bodyPr>
+          <a:lstStyle xmlns:a="http://schemas.openxmlformats.org/drawingml/2006/main"/>
+          <a:p xmlns:a="http://schemas.openxmlformats.org/drawingml/2006/main">
+            <a:pPr>
+              <a:buNone/>
+              <a:defRPr sz="1350">
+                <a:solidFill>
+                  <a:srgbClr val="30515F"/>
+                </a:solidFill>
+                <a:latin typeface="Calibri"/>
+                <a:ea typeface="Calibri"/>
+                <a:cs typeface="Calibri"/>
+              </a:defRPr>
+            </a:pPr>
+            <a:r>
+              <a:rPr sz="1350">
+                <a:solidFill>
+                  <a:srgbClr val="30515F"/>
+                </a:solidFill>
+                <a:latin typeface="Calibri"/>
+                <a:ea typeface="Calibri"/>
+                <a:cs typeface="Calibri"/>
+              </a:rPr>
+              <a:t>{{trace_caption}}</a:t>
+            </a:r>
+          </a:p>
+        </p:txBody>
+      </p:sp>
+      <p:sp>
+        <p:nvSpPr>
+          <p:cNvPr id="32" name="ctt:trace_passage_1">
+            <a:extLst xmlns:a="http://schemas.openxmlformats.org/drawingml/2006/main">
+              <a:ext uri="{FF2B5EF4-FFF2-40B4-BE49-F238E27FC236}">
+                <a16:creationId xmlns:a16="http://schemas.microsoft.com/office/drawing/2014/main" id="{701F30EC-0BE9-4FAB-AF63-0D89D2815A61}"/>
+              </a:ext>
+            </a:extLst>
+          </p:cNvPr>
+          <p:cNvSpPr>
+            <a:spLocks xmlns:a="http://schemas.openxmlformats.org/drawingml/2006/main" noGrp="1"/>
+          </p:cNvSpPr>
+          <p:nvPr/>
+        </p:nvSpPr>
+        <p:spPr>
+          <a:xfrm xmlns:a="http://schemas.openxmlformats.org/drawingml/2006/main">
+            <a:off x="571500" y="1666875"/>
+            <a:ext cx="3514725" cy="647700"/>
+          </a:xfrm>
+          <a:prstGeom xmlns:a="http://schemas.openxmlformats.org/drawingml/2006/main" prst="rect">
+            <a:avLst/>
+          </a:prstGeom>
+          <a:noFill xmlns:a="http://schemas.openxmlformats.org/drawingml/2006/main"/>
+          <a:ln xmlns:a="http://schemas.openxmlformats.org/drawingml/2006/main" w="0">
+            <a:noFill/>
+          </a:ln>
+        </p:spPr>
+        <p:txBody>
+          <a:bodyPr xmlns:a="http://schemas.openxmlformats.org/drawingml/2006/main" anchor="ctr">
+            <a:noAutofit/>
+          </a:bodyPr>
+          <a:lstStyle xmlns:a="http://schemas.openxmlformats.org/drawingml/2006/main"/>
+          <a:p xmlns:a="http://schemas.openxmlformats.org/drawingml/2006/main">
+            <a:pPr algn="ctr">
+              <a:buNone/>
+              <a:defRPr sz="1650" b="1">
+                <a:solidFill>
+                  <a:srgbClr val="30515F"/>
+                </a:solidFill>
+                <a:latin typeface="Calibri"/>
+                <a:ea typeface="Calibri"/>
+                <a:cs typeface="Calibri"/>
+              </a:defRPr>
+            </a:pPr>
+            <a:r>
+              <a:rPr sz="1650" b="1">
+                <a:solidFill>
+                  <a:srgbClr val="30515F"/>
+                </a:solidFill>
+                <a:latin typeface="Calibri"/>
+                <a:ea typeface="Calibri"/>
+                <a:cs typeface="Calibri"/>
+              </a:rPr>
+              <a:t>{{trace_passage_1}}</a:t>
+            </a:r>
+          </a:p>
+        </p:txBody>
+      </p:sp>
+      <p:sp>
+        <p:nvSpPr>
+          <p:cNvPr id="33" name="ctt:trace_picture_1">
+            <a:extLst xmlns:a="http://schemas.openxmlformats.org/drawingml/2006/main">
+              <a:ext uri="{FF2B5EF4-FFF2-40B4-BE49-F238E27FC236}">
+                <a16:creationId xmlns:a16="http://schemas.microsoft.com/office/drawing/2014/main" id="{4EE5E853-D52C-4B17-8392-79333EF11353}"/>
+              </a:ext>
+            </a:extLst>
+          </p:cNvPr>
+          <p:cNvSpPr>
+            <a:spLocks xmlns:a="http://schemas.openxmlformats.org/drawingml/2006/main" noGrp="1"/>
+          </p:cNvSpPr>
+          <p:nvPr>
+            <p:ph idx="0"/>
+          </p:nvPr>
+        </p:nvSpPr>
+        <p:spPr>
+          <a:xfrm xmlns:a="http://schemas.openxmlformats.org/drawingml/2006/main">
+            <a:off x="571500" y="2381250"/>
+            <a:ext cx="3514725" cy="3238500"/>
+          </a:xfrm>
+        </p:spPr>
+        <p:txBody>
+          <a:bodyPr xmlns:a="http://schemas.openxmlformats.org/drawingml/2006/main" anchor="ctr">
+            <a:noAutofit/>
+          </a:bodyPr>
+          <a:lstStyle xmlns:a="http://schemas.openxmlformats.org/drawingml/2006/main"/>
+          <a:p xmlns:a="http://schemas.openxmlformats.org/drawingml/2006/main">
+            <a:pPr algn="ctr">
+              <a:buNone/>
+              <a:defRPr sz="1800">
+                <a:solidFill>
+                  <a:srgbClr val="7F7F7F"/>
+                </a:solidFill>
+                <a:latin typeface="Calibri"/>
+                <a:ea typeface="Calibri"/>
+                <a:cs typeface="Calibri"/>
+              </a:defRPr>
+            </a:pPr>
+            <a:r>
+              <a:rPr sz="1800">
+                <a:solidFill>
+                  <a:srgbClr val="7F7F7F"/>
+                </a:solidFill>
+                <a:latin typeface="Calibri"/>
+                <a:ea typeface="Calibri"/>
+                <a:cs typeface="Calibri"/>
+              </a:rPr>
+              <a:t>{{trace_picture_1}}</a:t>
+            </a:r>
+          </a:p>
+        </p:txBody>
+      </p:sp>
+      <p:sp>
+        <p:nvSpPr>
+          <p:cNvPr id="34" name="ctt:trace_passage_2">
+            <a:extLst xmlns:a="http://schemas.openxmlformats.org/drawingml/2006/main">
+              <a:ext uri="{FF2B5EF4-FFF2-40B4-BE49-F238E27FC236}">
+                <a16:creationId xmlns:a16="http://schemas.microsoft.com/office/drawing/2014/main" id="{76FFBA67-0374-4635-879E-8D2FA522A943}"/>
+              </a:ext>
+            </a:extLst>
+          </p:cNvPr>
+          <p:cNvSpPr>
+            <a:spLocks xmlns:a="http://schemas.openxmlformats.org/drawingml/2006/main" noGrp="1"/>
+          </p:cNvSpPr>
+          <p:nvPr/>
+        </p:nvSpPr>
+        <p:spPr>
+          <a:xfrm xmlns:a="http://schemas.openxmlformats.org/drawingml/2006/main">
+            <a:off x="4314825" y="1666875"/>
+            <a:ext cx="3514725" cy="647700"/>
+          </a:xfrm>
+          <a:prstGeom xmlns:a="http://schemas.openxmlformats.org/drawingml/2006/main" prst="rect">
+            <a:avLst/>
+          </a:prstGeom>
+          <a:noFill xmlns:a="http://schemas.openxmlformats.org/drawingml/2006/main"/>
+          <a:ln xmlns:a="http://schemas.openxmlformats.org/drawingml/2006/main" w="0">
+            <a:noFill/>
+          </a:ln>
+        </p:spPr>
+        <p:txBody>
+          <a:bodyPr xmlns:a="http://schemas.openxmlformats.org/drawingml/2006/main" anchor="ctr">
+            <a:noAutofit/>
+          </a:bodyPr>
+          <a:lstStyle xmlns:a="http://schemas.openxmlformats.org/drawingml/2006/main"/>
+          <a:p xmlns:a="http://schemas.openxmlformats.org/drawingml/2006/main">
+            <a:pPr algn="ctr">
+              <a:buNone/>
+              <a:defRPr sz="1650" b="1">
+                <a:solidFill>
+                  <a:srgbClr val="30515F"/>
+                </a:solidFill>
+                <a:latin typeface="Calibri"/>
+                <a:ea typeface="Calibri"/>
+                <a:cs typeface="Calibri"/>
+              </a:defRPr>
+            </a:pPr>
+            <a:r>
+              <a:rPr sz="1650" b="1">
+                <a:solidFill>
+                  <a:srgbClr val="30515F"/>
+                </a:solidFill>
+                <a:latin typeface="Calibri"/>
+                <a:ea typeface="Calibri"/>
+                <a:cs typeface="Calibri"/>
+              </a:rPr>
+              <a:t>{{trace_passage_2}}</a:t>
+            </a:r>
+          </a:p>
+        </p:txBody>
+      </p:sp>
+      <p:sp>
+        <p:nvSpPr>
+          <p:cNvPr id="35" name="ctt:trace_picture_2">
+            <a:extLst xmlns:a="http://schemas.openxmlformats.org/drawingml/2006/main">
+              <a:ext uri="{FF2B5EF4-FFF2-40B4-BE49-F238E27FC236}">
+                <a16:creationId xmlns:a16="http://schemas.microsoft.com/office/drawing/2014/main" id="{351AF69C-149E-4EC3-8867-941429B018B0}"/>
+              </a:ext>
+            </a:extLst>
+          </p:cNvPr>
+          <p:cNvSpPr>
+            <a:spLocks xmlns:a="http://schemas.openxmlformats.org/drawingml/2006/main" noGrp="1"/>
+          </p:cNvSpPr>
+          <p:nvPr>
+            <p:ph idx="1"/>
+          </p:nvPr>
+        </p:nvSpPr>
+        <p:spPr>
+          <a:xfrm xmlns:a="http://schemas.openxmlformats.org/drawingml/2006/main">
+            <a:off x="4314825" y="2381250"/>
+            <a:ext cx="3514725" cy="3238500"/>
+          </a:xfrm>
+        </p:spPr>
+        <p:txBody>
+          <a:bodyPr xmlns:a="http://schemas.openxmlformats.org/drawingml/2006/main" anchor="ctr">
+            <a:noAutofit/>
+          </a:bodyPr>
+          <a:lstStyle xmlns:a="http://schemas.openxmlformats.org/drawingml/2006/main"/>
+          <a:p xmlns:a="http://schemas.openxmlformats.org/drawingml/2006/main">
+            <a:pPr algn="ctr">
+              <a:buNone/>
+              <a:defRPr sz="1800">
+                <a:solidFill>
+                  <a:srgbClr val="7F7F7F"/>
+                </a:solidFill>
+                <a:latin typeface="Calibri"/>
+                <a:ea typeface="Calibri"/>
+                <a:cs typeface="Calibri"/>
+              </a:defRPr>
+            </a:pPr>
+            <a:r>
+              <a:rPr sz="1800">
+                <a:solidFill>
+                  <a:srgbClr val="7F7F7F"/>
+                </a:solidFill>
+                <a:latin typeface="Calibri"/>
+                <a:ea typeface="Calibri"/>
+                <a:cs typeface="Calibri"/>
+              </a:rPr>
+              <a:t>{{trace_picture_2}}</a:t>
+            </a:r>
+          </a:p>
+        </p:txBody>
+      </p:sp>
+      <p:sp>
+        <p:nvSpPr>
+          <p:cNvPr id="36" name="ctt:trace_passage_3">
+            <a:extLst xmlns:a="http://schemas.openxmlformats.org/drawingml/2006/main">
+              <a:ext uri="{FF2B5EF4-FFF2-40B4-BE49-F238E27FC236}">
+                <a16:creationId xmlns:a16="http://schemas.microsoft.com/office/drawing/2014/main" id="{F5E2FAC9-9CE4-49AF-AD2F-2EFA1B81083E}"/>
+              </a:ext>
+            </a:extLst>
+          </p:cNvPr>
+          <p:cNvSpPr>
+            <a:spLocks xmlns:a="http://schemas.openxmlformats.org/drawingml/2006/main" noGrp="1"/>
+          </p:cNvSpPr>
+          <p:nvPr/>
+        </p:nvSpPr>
+        <p:spPr>
+          <a:xfrm xmlns:a="http://schemas.openxmlformats.org/drawingml/2006/main">
+            <a:off x="8058150" y="1666875"/>
+            <a:ext cx="3514725" cy="647700"/>
+          </a:xfrm>
+          <a:prstGeom xmlns:a="http://schemas.openxmlformats.org/drawingml/2006/main" prst="rect">
+            <a:avLst/>
+          </a:prstGeom>
+          <a:noFill xmlns:a="http://schemas.openxmlformats.org/drawingml/2006/main"/>
+          <a:ln xmlns:a="http://schemas.openxmlformats.org/drawingml/2006/main" w="0">
+            <a:noFill/>
+          </a:ln>
+        </p:spPr>
+        <p:txBody>
+          <a:bodyPr xmlns:a="http://schemas.openxmlformats.org/drawingml/2006/main" anchor="ctr">
+            <a:noAutofit/>
+          </a:bodyPr>
+          <a:lstStyle xmlns:a="http://schemas.openxmlformats.org/drawingml/2006/main"/>
+          <a:p xmlns:a="http://schemas.openxmlformats.org/drawingml/2006/main">
+            <a:pPr algn="ctr">
+              <a:buNone/>
+              <a:defRPr sz="1650" b="1">
+                <a:solidFill>
+                  <a:srgbClr val="30515F"/>
+                </a:solidFill>
+                <a:latin typeface="Calibri"/>
+                <a:ea typeface="Calibri"/>
+                <a:cs typeface="Calibri"/>
+              </a:defRPr>
+            </a:pPr>
+            <a:r>
+              <a:rPr sz="1650" b="1">
+                <a:solidFill>
+                  <a:srgbClr val="30515F"/>
+                </a:solidFill>
+                <a:latin typeface="Calibri"/>
+                <a:ea typeface="Calibri"/>
+                <a:cs typeface="Calibri"/>
+              </a:rPr>
+              <a:t>{{trace_passage_3}}</a:t>
+            </a:r>
+          </a:p>
+        </p:txBody>
+      </p:sp>
+      <p:sp>
+        <p:nvSpPr>
+          <p:cNvPr id="37" name="ctt:trace_picture_3">
+            <a:extLst xmlns:a="http://schemas.openxmlformats.org/drawingml/2006/main">
+              <a:ext uri="{FF2B5EF4-FFF2-40B4-BE49-F238E27FC236}">
+                <a16:creationId xmlns:a16="http://schemas.microsoft.com/office/drawing/2014/main" id="{1A6E1909-83F1-45FF-9946-6F7A5FE1A4A0}"/>
+              </a:ext>
+            </a:extLst>
+          </p:cNvPr>
+          <p:cNvSpPr>
+            <a:spLocks xmlns:a="http://schemas.openxmlformats.org/drawingml/2006/main" noGrp="1"/>
+          </p:cNvSpPr>
+          <p:nvPr>
+            <p:ph idx="2"/>
+          </p:nvPr>
+        </p:nvSpPr>
+        <p:spPr>
+          <a:xfrm xmlns:a="http://schemas.openxmlformats.org/drawingml/2006/main">
+            <a:off x="8058150" y="2381250"/>
+            <a:ext cx="3514725" cy="3238500"/>
+          </a:xfrm>
+        </p:spPr>
+        <p:txBody>
+          <a:bodyPr xmlns:a="http://schemas.openxmlformats.org/drawingml/2006/main" anchor="ctr">
+            <a:noAutofit/>
+          </a:bodyPr>
+          <a:lstStyle xmlns:a="http://schemas.openxmlformats.org/drawingml/2006/main"/>
+          <a:p xmlns:a="http://schemas.openxmlformats.org/drawingml/2006/main">
+            <a:pPr algn="ctr">
+              <a:buNone/>
+              <a:defRPr sz="1800">
+                <a:solidFill>
+                  <a:srgbClr val="7F7F7F"/>
+                </a:solidFill>
+                <a:latin typeface="Calibri"/>
+                <a:ea typeface="Calibri"/>
+                <a:cs typeface="Calibri"/>
+              </a:defRPr>
+            </a:pPr>
+            <a:r>
+              <a:rPr sz="1800">
+                <a:solidFill>
+                  <a:srgbClr val="7F7F7F"/>
+                </a:solidFill>
+                <a:latin typeface="Calibri"/>
+                <a:ea typeface="Calibri"/>
+                <a:cs typeface="Calibri"/>
+              </a:rPr>
+              <a:t>{{trace_picture_3}}</a:t>
             </a:r>
           </a:p>
         </p:txBody>
@@ -5843,7 +7440,7 @@
           <p:nvPr/>
         </p:nvPicPr>
         <p:blipFill>
-          <a:blip xmlns:r="http://schemas.openxmlformats.org/officeDocument/2006/relationships" xmlns:a="http://schemas.openxmlformats.org/drawingml/2006/main" r:embed="R9ce0c25d85ff4f4d"/>
+          <a:blip xmlns:r="http://schemas.openxmlformats.org/officeDocument/2006/relationships" xmlns:a="http://schemas.openxmlformats.org/drawingml/2006/main" r:embed="Rbdbfc6084322495b"/>
           <a:stretch xmlns:a="http://schemas.openxmlformats.org/drawingml/2006/main">
             <a:fillRect l="0" t="0" r="0" b="0"/>
           </a:stretch>
@@ -5968,8 +7565,8 @@
         </p:nvSpPr>
         <p:spPr>
           <a:xfrm xmlns:a="http://schemas.openxmlformats.org/drawingml/2006/main">
-            <a:off x="658368" y="2231136"/>
-            <a:ext cx="4114800" cy="384048"/>
+            <a:off x="658368" y="3143250"/>
+            <a:ext cx="8572500" cy="1714500"/>
           </a:xfrm>
           <a:prstGeom xmlns:a="http://schemas.openxmlformats.org/drawingml/2006/main" prst="rect">
             <a:avLst/>
@@ -5978,12 +7575,20 @@
         </p:spPr>
         <p:txBody>
           <a:bodyPr xmlns:a="http://schemas.openxmlformats.org/drawingml/2006/main" wrap="none" lIns="0" tIns="0" rIns="0" bIns="0" anchor="ctr">
-            <a:spAutoFit/>
+            <a:noAutofit/>
           </a:bodyPr>
           <a:lstStyle xmlns:a="http://schemas.openxmlformats.org/drawingml/2006/main"/>
           <a:p xmlns:a="http://schemas.openxmlformats.org/drawingml/2006/main">
             <a:pPr algn="l">
               <a:buNone/>
+              <a:defRPr sz="1850">
+                <a:solidFill>
+                  <a:srgbClr val="FFFFFF"/>
+                </a:solidFill>
+                <a:latin typeface="Calibri"/>
+                <a:ea typeface="Calibri"/>
+                <a:cs typeface="Calibri"/>
+              </a:defRPr>
             </a:pPr>
             <a:r>
               <a:rPr sz="1850" b="0">
@@ -6188,7 +7793,7 @@
           <p:nvPr/>
         </p:nvPicPr>
         <p:blipFill>
-          <a:blip xmlns:r="http://schemas.openxmlformats.org/officeDocument/2006/relationships" xmlns:a="http://schemas.openxmlformats.org/drawingml/2006/main" r:embed="Red4686f917e645ea"/>
+          <a:blip xmlns:r="http://schemas.openxmlformats.org/officeDocument/2006/relationships" xmlns:a="http://schemas.openxmlformats.org/drawingml/2006/main" r:embed="R38ca57d17415484d"/>
           <a:stretch xmlns:a="http://schemas.openxmlformats.org/drawingml/2006/main">
             <a:fillRect l="0" t="0" r="0" b="0"/>
           </a:stretch>
@@ -6487,6 +8092,7 @@
           <a:lstStyle xmlns:a="http://schemas.openxmlformats.org/drawingml/2006/main"/>
           <a:p xmlns:a="http://schemas.openxmlformats.org/drawingml/2006/main">
             <a:pPr>
+              <a:buNone/>
               <a:defRPr sz="1800">
                 <a:solidFill>
                   <a:srgbClr val="FFFFFF"/>
@@ -7528,7 +9134,7 @@
           <p:nvPr/>
         </p:nvPicPr>
         <p:blipFill>
-          <a:blip xmlns:r="http://schemas.openxmlformats.org/officeDocument/2006/relationships" xmlns:a="http://schemas.openxmlformats.org/drawingml/2006/main" r:embed="R61f303d6ef014810"/>
+          <a:blip xmlns:r="http://schemas.openxmlformats.org/officeDocument/2006/relationships" xmlns:a="http://schemas.openxmlformats.org/drawingml/2006/main" r:embed="R92026fec069b41b4"/>
           <a:stretch xmlns:a="http://schemas.openxmlformats.org/drawingml/2006/main">
             <a:fillRect l="0" t="0" r="0" b="0"/>
           </a:stretch>
@@ -8673,7 +10279,7 @@
           <p:nvPr/>
         </p:nvPicPr>
         <p:blipFill>
-          <a:blip xmlns:r="http://schemas.openxmlformats.org/officeDocument/2006/relationships" xmlns:a="http://schemas.openxmlformats.org/drawingml/2006/main" r:embed="R0836176b7e8a4e66"/>
+          <a:blip xmlns:r="http://schemas.openxmlformats.org/officeDocument/2006/relationships" xmlns:a="http://schemas.openxmlformats.org/drawingml/2006/main" r:embed="R673b5a90ccf24155"/>
           <a:stretch xmlns:a="http://schemas.openxmlformats.org/drawingml/2006/main">
             <a:fillRect l="0" t="0" r="0" b="0"/>
           </a:stretch>
@@ -8967,9 +10573,67 @@
           </a:p>
         </p:txBody>
       </p:sp>
+      <p:sp>
+        <p:nvSpPr>
+          <p:cNvPr id="29" name="ctt:table_caption">
+            <a:extLst xmlns:a="http://schemas.openxmlformats.org/drawingml/2006/main">
+              <a:ext uri="{FF2B5EF4-FFF2-40B4-BE49-F238E27FC236}">
+                <a16:creationId xmlns:a16="http://schemas.microsoft.com/office/drawing/2014/main" id="{CC680E71-DBB8-4A43-840D-212DE658277C}"/>
+              </a:ext>
+            </a:extLst>
+          </p:cNvPr>
+          <p:cNvSpPr>
+            <a:spLocks xmlns:a="http://schemas.openxmlformats.org/drawingml/2006/main" noGrp="1"/>
+          </p:cNvSpPr>
+          <p:nvPr/>
+        </p:nvSpPr>
+        <p:spPr>
+          <a:xfrm xmlns:a="http://schemas.openxmlformats.org/drawingml/2006/main">
+            <a:off x="571500" y="6010275"/>
+            <a:ext cx="11001375" cy="276225"/>
+          </a:xfrm>
+          <a:prstGeom xmlns:a="http://schemas.openxmlformats.org/drawingml/2006/main" prst="rect">
+            <a:avLst/>
+          </a:prstGeom>
+          <a:noFill xmlns:a="http://schemas.openxmlformats.org/drawingml/2006/main"/>
+          <a:ln xmlns:a="http://schemas.openxmlformats.org/drawingml/2006/main" w="0">
+            <a:noFill/>
+          </a:ln>
+        </p:spPr>
+        <p:txBody>
+          <a:bodyPr xmlns:a="http://schemas.openxmlformats.org/drawingml/2006/main">
+            <a:noAutofit/>
+          </a:bodyPr>
+          <a:lstStyle xmlns:a="http://schemas.openxmlformats.org/drawingml/2006/main"/>
+          <a:p xmlns:a="http://schemas.openxmlformats.org/drawingml/2006/main">
+            <a:pPr>
+              <a:buNone/>
+              <a:defRPr sz="1350">
+                <a:solidFill>
+                  <a:srgbClr val="30515F"/>
+                </a:solidFill>
+                <a:latin typeface="Calibri"/>
+                <a:ea typeface="Calibri"/>
+                <a:cs typeface="Calibri"/>
+              </a:defRPr>
+            </a:pPr>
+            <a:r>
+              <a:rPr sz="1350">
+                <a:solidFill>
+                  <a:srgbClr val="30515F"/>
+                </a:solidFill>
+                <a:latin typeface="Calibri"/>
+                <a:ea typeface="Calibri"/>
+                <a:cs typeface="Calibri"/>
+              </a:rPr>
+              <a:t>{{table_caption}}</a:t>
+            </a:r>
+          </a:p>
+        </p:txBody>
+      </p:sp>
       <p:graphicFrame>
         <p:nvGraphicFramePr>
-          <p:cNvPr id="38" name=""/>
+          <p:cNvPr id="39" name=""/>
           <p:cNvGraphicFramePr/>
           <p:nvPr/>
         </p:nvGraphicFramePr>
@@ -8982,11 +10646,12 @@
             <a:tbl>
               <a:tblPr firstRow="1" bandRow="0"/>
               <a:tblGrid>
-                <a:gridCol w="1095375"/>
-                <a:gridCol w="3524250"/>
-                <a:gridCol w="2190750"/>
-                <a:gridCol w="2190750"/>
-                <a:gridCol w="2000250"/>
+                <a:gridCol w="904875"/>
+                <a:gridCol w="2428875"/>
+                <a:gridCol w="2047875"/>
+                <a:gridCol w="2047875"/>
+                <a:gridCol w="1190625"/>
+                <a:gridCol w="2381250"/>
               </a:tblGrid>
               <a:tr h="533400">
                 <a:tc>
@@ -9007,7 +10672,7 @@
                       </a:r>
                     </a:p>
                   </a:txBody>
-                  <a:tcPr marL="95250" marR="95250" marT="28575" marB="28575" anchor="ctr" horzOverflow="wrap">
+                  <a:tcPr marL="95250" marR="95250" marT="28575" marB="28575" anchor="ctr" horzOverflow="overflow">
                     <a:solidFill>
                       <a:srgbClr val="30515F"/>
                     </a:solidFill>
@@ -9031,7 +10696,7 @@
                       </a:r>
                     </a:p>
                   </a:txBody>
-                  <a:tcPr marL="95250" marR="95250" marT="28575" marB="28575" anchor="ctr" horzOverflow="wrap">
+                  <a:tcPr marL="95250" marR="95250" marT="28575" marB="28575" anchor="ctr" horzOverflow="overflow">
                     <a:solidFill>
                       <a:srgbClr val="30515F"/>
                     </a:solidFill>
@@ -9055,7 +10720,7 @@
                       </a:r>
                     </a:p>
                   </a:txBody>
-                  <a:tcPr marL="95250" marR="95250" marT="28575" marB="28575" anchor="ctr" horzOverflow="wrap">
+                  <a:tcPr marL="95250" marR="95250" marT="28575" marB="28575" anchor="ctr" horzOverflow="overflow">
                     <a:solidFill>
                       <a:srgbClr val="30515F"/>
                     </a:solidFill>
@@ -9079,7 +10744,7 @@
                       </a:r>
                     </a:p>
                   </a:txBody>
-                  <a:tcPr marL="95250" marR="95250" marT="28575" marB="28575" anchor="ctr" horzOverflow="wrap">
+                  <a:tcPr marL="95250" marR="95250" marT="28575" marB="28575" anchor="ctr" horzOverflow="overflow">
                     <a:solidFill>
                       <a:srgbClr val="30515F"/>
                     </a:solidFill>
@@ -9103,7 +10768,31 @@
                       </a:r>
                     </a:p>
                   </a:txBody>
-                  <a:tcPr marL="95250" marR="95250" marT="28575" marB="28575" anchor="ctr" horzOverflow="wrap">
+                  <a:tcPr marL="95250" marR="95250" marT="28575" marB="28575" anchor="ctr" horzOverflow="overflow">
+                    <a:solidFill>
+                      <a:srgbClr val="30515F"/>
+                    </a:solidFill>
+                  </a:tcPr>
+                </a:tc>
+                <a:tc>
+                  <a:txBody>
+                    <a:bodyPr/>
+                    <a:lstStyle/>
+                    <a:p>
+                      <a:r>
+                        <a:rPr sz="1650" b="1">
+                          <a:solidFill>
+                            <a:srgbClr val="FFFFFF"/>
+                          </a:solidFill>
+                          <a:latin typeface="Calibri"/>
+                          <a:ea typeface="Calibri"/>
+                          <a:cs typeface="Calibri"/>
+                        </a:rPr>
+                        <a:t>Talhões no retorno</a:t>
+                      </a:r>
+                    </a:p>
+                  </a:txBody>
+                  <a:tcPr marL="95250" marR="95250" marT="28575" marB="28575" anchor="ctr" horzOverflow="overflow">
                     <a:solidFill>
                       <a:srgbClr val="30515F"/>
                     </a:solidFill>
@@ -9129,7 +10818,7 @@
                       </a:r>
                     </a:p>
                   </a:txBody>
-                  <a:tcPr marL="95250" marR="95250" marT="28575" marB="28575" anchor="ctr" horzOverflow="wrap">
+                  <a:tcPr marL="95250" marR="95250" marT="28575" marB="28575" anchor="ctr" horzOverflow="overflow">
                     <a:solidFill>
                       <a:srgbClr val="F5F8F6"/>
                     </a:solidFill>
@@ -9153,7 +10842,7 @@
                       </a:r>
                     </a:p>
                   </a:txBody>
-                  <a:tcPr marL="95250" marR="95250" marT="28575" marB="28575" anchor="ctr" horzOverflow="wrap">
+                  <a:tcPr marL="95250" marR="95250" marT="28575" marB="28575" anchor="ctr" horzOverflow="overflow">
                     <a:solidFill>
                       <a:srgbClr val="F5F8F6"/>
                     </a:solidFill>
@@ -9177,7 +10866,7 @@
                       </a:r>
                     </a:p>
                   </a:txBody>
-                  <a:tcPr marL="95250" marR="95250" marT="28575" marB="28575" anchor="ctr" horzOverflow="wrap">
+                  <a:tcPr marL="95250" marR="95250" marT="28575" marB="28575" anchor="ctr" horzOverflow="overflow">
                     <a:solidFill>
                       <a:srgbClr val="F5F8F6"/>
                     </a:solidFill>
@@ -9201,7 +10890,7 @@
                       </a:r>
                     </a:p>
                   </a:txBody>
-                  <a:tcPr marL="95250" marR="95250" marT="28575" marB="28575" anchor="ctr" horzOverflow="wrap">
+                  <a:tcPr marL="95250" marR="95250" marT="28575" marB="28575" anchor="ctr" horzOverflow="overflow">
                     <a:solidFill>
                       <a:srgbClr val="F5F8F6"/>
                     </a:solidFill>
@@ -9225,7 +10914,31 @@
                       </a:r>
                     </a:p>
                   </a:txBody>
-                  <a:tcPr marL="95250" marR="95250" marT="28575" marB="28575" anchor="ctr" horzOverflow="wrap">
+                  <a:tcPr marL="95250" marR="95250" marT="28575" marB="28575" anchor="ctr" horzOverflow="overflow">
+                    <a:solidFill>
+                      <a:srgbClr val="F5F8F6"/>
+                    </a:solidFill>
+                  </a:tcPr>
+                </a:tc>
+                <a:tc>
+                  <a:txBody>
+                    <a:bodyPr/>
+                    <a:lstStyle/>
+                    <a:p>
+                      <a:r>
+                        <a:rPr sz="1800">
+                          <a:solidFill>
+                            <a:srgbClr val="30515F"/>
+                          </a:solidFill>
+                          <a:latin typeface="Calibri"/>
+                          <a:ea typeface="Calibri"/>
+                          <a:cs typeface="Calibri"/>
+                        </a:rPr>
+                        <a:t/>
+                      </a:r>
+                    </a:p>
+                  </a:txBody>
+                  <a:tcPr marL="95250" marR="95250" marT="28575" marB="28575" anchor="ctr" horzOverflow="overflow">
                     <a:solidFill>
                       <a:srgbClr val="F5F8F6"/>
                     </a:solidFill>
@@ -9251,7 +10964,7 @@
                       </a:r>
                     </a:p>
                   </a:txBody>
-                  <a:tcPr marL="95250" marR="95250" marT="28575" marB="28575" anchor="ctr" horzOverflow="wrap">
+                  <a:tcPr marL="95250" marR="95250" marT="28575" marB="28575" anchor="ctr" horzOverflow="overflow">
                     <a:solidFill>
                       <a:srgbClr val="FFFFFF"/>
                     </a:solidFill>
@@ -9275,7 +10988,7 @@
                       </a:r>
                     </a:p>
                   </a:txBody>
-                  <a:tcPr marL="95250" marR="95250" marT="28575" marB="28575" anchor="ctr" horzOverflow="wrap">
+                  <a:tcPr marL="95250" marR="95250" marT="28575" marB="28575" anchor="ctr" horzOverflow="overflow">
                     <a:solidFill>
                       <a:srgbClr val="FFFFFF"/>
                     </a:solidFill>
@@ -9299,7 +11012,7 @@
                       </a:r>
                     </a:p>
                   </a:txBody>
-                  <a:tcPr marL="95250" marR="95250" marT="28575" marB="28575" anchor="ctr" horzOverflow="wrap">
+                  <a:tcPr marL="95250" marR="95250" marT="28575" marB="28575" anchor="ctr" horzOverflow="overflow">
                     <a:solidFill>
                       <a:srgbClr val="FFFFFF"/>
                     </a:solidFill>
@@ -9323,7 +11036,7 @@
                       </a:r>
                     </a:p>
                   </a:txBody>
-                  <a:tcPr marL="95250" marR="95250" marT="28575" marB="28575" anchor="ctr" horzOverflow="wrap">
+                  <a:tcPr marL="95250" marR="95250" marT="28575" marB="28575" anchor="ctr" horzOverflow="overflow">
                     <a:solidFill>
                       <a:srgbClr val="FFFFFF"/>
                     </a:solidFill>
@@ -9347,7 +11060,31 @@
                       </a:r>
                     </a:p>
                   </a:txBody>
-                  <a:tcPr marL="95250" marR="95250" marT="28575" marB="28575" anchor="ctr" horzOverflow="wrap">
+                  <a:tcPr marL="95250" marR="95250" marT="28575" marB="28575" anchor="ctr" horzOverflow="overflow">
+                    <a:solidFill>
+                      <a:srgbClr val="FFFFFF"/>
+                    </a:solidFill>
+                  </a:tcPr>
+                </a:tc>
+                <a:tc>
+                  <a:txBody>
+                    <a:bodyPr/>
+                    <a:lstStyle/>
+                    <a:p>
+                      <a:r>
+                        <a:rPr sz="1800">
+                          <a:solidFill>
+                            <a:srgbClr val="30515F"/>
+                          </a:solidFill>
+                          <a:latin typeface="Calibri"/>
+                          <a:ea typeface="Calibri"/>
+                          <a:cs typeface="Calibri"/>
+                        </a:rPr>
+                        <a:t/>
+                      </a:r>
+                    </a:p>
+                  </a:txBody>
+                  <a:tcPr marL="95250" marR="95250" marT="28575" marB="28575" anchor="ctr" horzOverflow="overflow">
                     <a:solidFill>
                       <a:srgbClr val="FFFFFF"/>
                     </a:solidFill>
@@ -9373,7 +11110,7 @@
                       </a:r>
                     </a:p>
                   </a:txBody>
-                  <a:tcPr marL="95250" marR="95250" marT="28575" marB="28575" anchor="ctr" horzOverflow="wrap">
+                  <a:tcPr marL="95250" marR="95250" marT="28575" marB="28575" anchor="ctr" horzOverflow="overflow">
                     <a:solidFill>
                       <a:srgbClr val="F5F8F6"/>
                     </a:solidFill>
@@ -9397,7 +11134,7 @@
                       </a:r>
                     </a:p>
                   </a:txBody>
-                  <a:tcPr marL="95250" marR="95250" marT="28575" marB="28575" anchor="ctr" horzOverflow="wrap">
+                  <a:tcPr marL="95250" marR="95250" marT="28575" marB="28575" anchor="ctr" horzOverflow="overflow">
                     <a:solidFill>
                       <a:srgbClr val="F5F8F6"/>
                     </a:solidFill>
@@ -9421,7 +11158,7 @@
                       </a:r>
                     </a:p>
                   </a:txBody>
-                  <a:tcPr marL="95250" marR="95250" marT="28575" marB="28575" anchor="ctr" horzOverflow="wrap">
+                  <a:tcPr marL="95250" marR="95250" marT="28575" marB="28575" anchor="ctr" horzOverflow="overflow">
                     <a:solidFill>
                       <a:srgbClr val="F5F8F6"/>
                     </a:solidFill>
@@ -9445,7 +11182,7 @@
                       </a:r>
                     </a:p>
                   </a:txBody>
-                  <a:tcPr marL="95250" marR="95250" marT="28575" marB="28575" anchor="ctr" horzOverflow="wrap">
+                  <a:tcPr marL="95250" marR="95250" marT="28575" marB="28575" anchor="ctr" horzOverflow="overflow">
                     <a:solidFill>
                       <a:srgbClr val="F5F8F6"/>
                     </a:solidFill>
@@ -9469,7 +11206,31 @@
                       </a:r>
                     </a:p>
                   </a:txBody>
-                  <a:tcPr marL="95250" marR="95250" marT="28575" marB="28575" anchor="ctr" horzOverflow="wrap">
+                  <a:tcPr marL="95250" marR="95250" marT="28575" marB="28575" anchor="ctr" horzOverflow="overflow">
+                    <a:solidFill>
+                      <a:srgbClr val="F5F8F6"/>
+                    </a:solidFill>
+                  </a:tcPr>
+                </a:tc>
+                <a:tc>
+                  <a:txBody>
+                    <a:bodyPr/>
+                    <a:lstStyle/>
+                    <a:p>
+                      <a:r>
+                        <a:rPr sz="1800">
+                          <a:solidFill>
+                            <a:srgbClr val="30515F"/>
+                          </a:solidFill>
+                          <a:latin typeface="Calibri"/>
+                          <a:ea typeface="Calibri"/>
+                          <a:cs typeface="Calibri"/>
+                        </a:rPr>
+                        <a:t/>
+                      </a:r>
+                    </a:p>
+                  </a:txBody>
+                  <a:tcPr marL="95250" marR="95250" marT="28575" marB="28575" anchor="ctr" horzOverflow="overflow">
                     <a:solidFill>
                       <a:srgbClr val="F5F8F6"/>
                     </a:solidFill>
@@ -9495,7 +11256,7 @@
                       </a:r>
                     </a:p>
                   </a:txBody>
-                  <a:tcPr marL="95250" marR="95250" marT="28575" marB="28575" anchor="ctr" horzOverflow="wrap">
+                  <a:tcPr marL="95250" marR="95250" marT="28575" marB="28575" anchor="ctr" horzOverflow="overflow">
                     <a:solidFill>
                       <a:srgbClr val="FFFFFF"/>
                     </a:solidFill>
@@ -9519,7 +11280,7 @@
                       </a:r>
                     </a:p>
                   </a:txBody>
-                  <a:tcPr marL="95250" marR="95250" marT="28575" marB="28575" anchor="ctr" horzOverflow="wrap">
+                  <a:tcPr marL="95250" marR="95250" marT="28575" marB="28575" anchor="ctr" horzOverflow="overflow">
                     <a:solidFill>
                       <a:srgbClr val="FFFFFF"/>
                     </a:solidFill>
@@ -9543,7 +11304,7 @@
                       </a:r>
                     </a:p>
                   </a:txBody>
-                  <a:tcPr marL="95250" marR="95250" marT="28575" marB="28575" anchor="ctr" horzOverflow="wrap">
+                  <a:tcPr marL="95250" marR="95250" marT="28575" marB="28575" anchor="ctr" horzOverflow="overflow">
                     <a:solidFill>
                       <a:srgbClr val="FFFFFF"/>
                     </a:solidFill>
@@ -9567,7 +11328,7 @@
                       </a:r>
                     </a:p>
                   </a:txBody>
-                  <a:tcPr marL="95250" marR="95250" marT="28575" marB="28575" anchor="ctr" horzOverflow="wrap">
+                  <a:tcPr marL="95250" marR="95250" marT="28575" marB="28575" anchor="ctr" horzOverflow="overflow">
                     <a:solidFill>
                       <a:srgbClr val="FFFFFF"/>
                     </a:solidFill>
@@ -9591,7 +11352,31 @@
                       </a:r>
                     </a:p>
                   </a:txBody>
-                  <a:tcPr marL="95250" marR="95250" marT="28575" marB="28575" anchor="ctr" horzOverflow="wrap">
+                  <a:tcPr marL="95250" marR="95250" marT="28575" marB="28575" anchor="ctr" horzOverflow="overflow">
+                    <a:solidFill>
+                      <a:srgbClr val="FFFFFF"/>
+                    </a:solidFill>
+                  </a:tcPr>
+                </a:tc>
+                <a:tc>
+                  <a:txBody>
+                    <a:bodyPr/>
+                    <a:lstStyle/>
+                    <a:p>
+                      <a:r>
+                        <a:rPr sz="1800">
+                          <a:solidFill>
+                            <a:srgbClr val="30515F"/>
+                          </a:solidFill>
+                          <a:latin typeface="Calibri"/>
+                          <a:ea typeface="Calibri"/>
+                          <a:cs typeface="Calibri"/>
+                        </a:rPr>
+                        <a:t/>
+                      </a:r>
+                    </a:p>
+                  </a:txBody>
+                  <a:tcPr marL="95250" marR="95250" marT="28575" marB="28575" anchor="ctr" horzOverflow="overflow">
                     <a:solidFill>
                       <a:srgbClr val="FFFFFF"/>
                     </a:solidFill>
@@ -9617,7 +11402,7 @@
                       </a:r>
                     </a:p>
                   </a:txBody>
-                  <a:tcPr marL="95250" marR="95250" marT="28575" marB="28575" anchor="ctr" horzOverflow="wrap">
+                  <a:tcPr marL="95250" marR="95250" marT="28575" marB="28575" anchor="ctr" horzOverflow="overflow">
                     <a:solidFill>
                       <a:srgbClr val="F5F8F6"/>
                     </a:solidFill>
@@ -9641,7 +11426,7 @@
                       </a:r>
                     </a:p>
                   </a:txBody>
-                  <a:tcPr marL="95250" marR="95250" marT="28575" marB="28575" anchor="ctr" horzOverflow="wrap">
+                  <a:tcPr marL="95250" marR="95250" marT="28575" marB="28575" anchor="ctr" horzOverflow="overflow">
                     <a:solidFill>
                       <a:srgbClr val="F5F8F6"/>
                     </a:solidFill>
@@ -9665,7 +11450,7 @@
                       </a:r>
                     </a:p>
                   </a:txBody>
-                  <a:tcPr marL="95250" marR="95250" marT="28575" marB="28575" anchor="ctr" horzOverflow="wrap">
+                  <a:tcPr marL="95250" marR="95250" marT="28575" marB="28575" anchor="ctr" horzOverflow="overflow">
                     <a:solidFill>
                       <a:srgbClr val="F5F8F6"/>
                     </a:solidFill>
@@ -9689,7 +11474,7 @@
                       </a:r>
                     </a:p>
                   </a:txBody>
-                  <a:tcPr marL="95250" marR="95250" marT="28575" marB="28575" anchor="ctr" horzOverflow="wrap">
+                  <a:tcPr marL="95250" marR="95250" marT="28575" marB="28575" anchor="ctr" horzOverflow="overflow">
                     <a:solidFill>
                       <a:srgbClr val="F5F8F6"/>
                     </a:solidFill>
@@ -9713,7 +11498,31 @@
                       </a:r>
                     </a:p>
                   </a:txBody>
-                  <a:tcPr marL="95250" marR="95250" marT="28575" marB="28575" anchor="ctr" horzOverflow="wrap">
+                  <a:tcPr marL="95250" marR="95250" marT="28575" marB="28575" anchor="ctr" horzOverflow="overflow">
+                    <a:solidFill>
+                      <a:srgbClr val="F5F8F6"/>
+                    </a:solidFill>
+                  </a:tcPr>
+                </a:tc>
+                <a:tc>
+                  <a:txBody>
+                    <a:bodyPr/>
+                    <a:lstStyle/>
+                    <a:p>
+                      <a:r>
+                        <a:rPr sz="1800">
+                          <a:solidFill>
+                            <a:srgbClr val="30515F"/>
+                          </a:solidFill>
+                          <a:latin typeface="Calibri"/>
+                          <a:ea typeface="Calibri"/>
+                          <a:cs typeface="Calibri"/>
+                        </a:rPr>
+                        <a:t/>
+                      </a:r>
+                    </a:p>
+                  </a:txBody>
+                  <a:tcPr marL="95250" marR="95250" marT="28575" marB="28575" anchor="ctr" horzOverflow="overflow">
                     <a:solidFill>
                       <a:srgbClr val="F5F8F6"/>
                     </a:solidFill>
@@ -9739,7 +11548,7 @@
                       </a:r>
                     </a:p>
                   </a:txBody>
-                  <a:tcPr marL="95250" marR="95250" marT="28575" marB="28575" anchor="ctr" horzOverflow="wrap">
+                  <a:tcPr marL="95250" marR="95250" marT="28575" marB="28575" anchor="ctr" horzOverflow="overflow">
                     <a:solidFill>
                       <a:srgbClr val="FFFFFF"/>
                     </a:solidFill>
@@ -9763,7 +11572,7 @@
                       </a:r>
                     </a:p>
                   </a:txBody>
-                  <a:tcPr marL="95250" marR="95250" marT="28575" marB="28575" anchor="ctr" horzOverflow="wrap">
+                  <a:tcPr marL="95250" marR="95250" marT="28575" marB="28575" anchor="ctr" horzOverflow="overflow">
                     <a:solidFill>
                       <a:srgbClr val="FFFFFF"/>
                     </a:solidFill>
@@ -9787,7 +11596,7 @@
                       </a:r>
                     </a:p>
                   </a:txBody>
-                  <a:tcPr marL="95250" marR="95250" marT="28575" marB="28575" anchor="ctr" horzOverflow="wrap">
+                  <a:tcPr marL="95250" marR="95250" marT="28575" marB="28575" anchor="ctr" horzOverflow="overflow">
                     <a:solidFill>
                       <a:srgbClr val="FFFFFF"/>
                     </a:solidFill>
@@ -9811,7 +11620,7 @@
                       </a:r>
                     </a:p>
                   </a:txBody>
-                  <a:tcPr marL="95250" marR="95250" marT="28575" marB="28575" anchor="ctr" horzOverflow="wrap">
+                  <a:tcPr marL="95250" marR="95250" marT="28575" marB="28575" anchor="ctr" horzOverflow="overflow">
                     <a:solidFill>
                       <a:srgbClr val="FFFFFF"/>
                     </a:solidFill>
@@ -9835,7 +11644,31 @@
                       </a:r>
                     </a:p>
                   </a:txBody>
-                  <a:tcPr marL="95250" marR="95250" marT="28575" marB="28575" anchor="ctr" horzOverflow="wrap">
+                  <a:tcPr marL="95250" marR="95250" marT="28575" marB="28575" anchor="ctr" horzOverflow="overflow">
+                    <a:solidFill>
+                      <a:srgbClr val="FFFFFF"/>
+                    </a:solidFill>
+                  </a:tcPr>
+                </a:tc>
+                <a:tc>
+                  <a:txBody>
+                    <a:bodyPr/>
+                    <a:lstStyle/>
+                    <a:p>
+                      <a:r>
+                        <a:rPr sz="1800">
+                          <a:solidFill>
+                            <a:srgbClr val="30515F"/>
+                          </a:solidFill>
+                          <a:latin typeface="Calibri"/>
+                          <a:ea typeface="Calibri"/>
+                          <a:cs typeface="Calibri"/>
+                        </a:rPr>
+                        <a:t/>
+                      </a:r>
+                    </a:p>
+                  </a:txBody>
+                  <a:tcPr marL="95250" marR="95250" marT="28575" marB="28575" anchor="ctr" horzOverflow="overflow">
                     <a:solidFill>
                       <a:srgbClr val="FFFFFF"/>
                     </a:solidFill>
@@ -9861,7 +11694,7 @@
                       </a:r>
                     </a:p>
                   </a:txBody>
-                  <a:tcPr marL="95250" marR="95250" marT="28575" marB="28575" anchor="ctr" horzOverflow="wrap">
+                  <a:tcPr marL="95250" marR="95250" marT="28575" marB="28575" anchor="ctr" horzOverflow="overflow">
                     <a:solidFill>
                       <a:srgbClr val="F5F8F6"/>
                     </a:solidFill>
@@ -9885,7 +11718,7 @@
                       </a:r>
                     </a:p>
                   </a:txBody>
-                  <a:tcPr marL="95250" marR="95250" marT="28575" marB="28575" anchor="ctr" horzOverflow="wrap">
+                  <a:tcPr marL="95250" marR="95250" marT="28575" marB="28575" anchor="ctr" horzOverflow="overflow">
                     <a:solidFill>
                       <a:srgbClr val="F5F8F6"/>
                     </a:solidFill>
@@ -9909,7 +11742,7 @@
                       </a:r>
                     </a:p>
                   </a:txBody>
-                  <a:tcPr marL="95250" marR="95250" marT="28575" marB="28575" anchor="ctr" horzOverflow="wrap">
+                  <a:tcPr marL="95250" marR="95250" marT="28575" marB="28575" anchor="ctr" horzOverflow="overflow">
                     <a:solidFill>
                       <a:srgbClr val="F5F8F6"/>
                     </a:solidFill>
@@ -9933,7 +11766,7 @@
                       </a:r>
                     </a:p>
                   </a:txBody>
-                  <a:tcPr marL="95250" marR="95250" marT="28575" marB="28575" anchor="ctr" horzOverflow="wrap">
+                  <a:tcPr marL="95250" marR="95250" marT="28575" marB="28575" anchor="ctr" horzOverflow="overflow">
                     <a:solidFill>
                       <a:srgbClr val="F5F8F6"/>
                     </a:solidFill>
@@ -9957,7 +11790,31 @@
                       </a:r>
                     </a:p>
                   </a:txBody>
-                  <a:tcPr marL="95250" marR="95250" marT="28575" marB="28575" anchor="ctr" horzOverflow="wrap">
+                  <a:tcPr marL="95250" marR="95250" marT="28575" marB="28575" anchor="ctr" horzOverflow="overflow">
+                    <a:solidFill>
+                      <a:srgbClr val="F5F8F6"/>
+                    </a:solidFill>
+                  </a:tcPr>
+                </a:tc>
+                <a:tc>
+                  <a:txBody>
+                    <a:bodyPr/>
+                    <a:lstStyle/>
+                    <a:p>
+                      <a:r>
+                        <a:rPr sz="1800">
+                          <a:solidFill>
+                            <a:srgbClr val="30515F"/>
+                          </a:solidFill>
+                          <a:latin typeface="Calibri"/>
+                          <a:ea typeface="Calibri"/>
+                          <a:cs typeface="Calibri"/>
+                        </a:rPr>
+                        <a:t/>
+                      </a:r>
+                    </a:p>
+                  </a:txBody>
+                  <a:tcPr marL="95250" marR="95250" marT="28575" marB="28575" anchor="ctr" horzOverflow="overflow">
                     <a:solidFill>
                       <a:srgbClr val="F5F8F6"/>
                     </a:solidFill>
@@ -9983,7 +11840,7 @@
                       </a:r>
                     </a:p>
                   </a:txBody>
-                  <a:tcPr marL="95250" marR="95250" marT="28575" marB="28575" anchor="ctr" horzOverflow="wrap">
+                  <a:tcPr marL="95250" marR="95250" marT="28575" marB="28575" anchor="ctr" horzOverflow="overflow">
                     <a:solidFill>
                       <a:srgbClr val="FFFFFF"/>
                     </a:solidFill>
@@ -10007,7 +11864,7 @@
                       </a:r>
                     </a:p>
                   </a:txBody>
-                  <a:tcPr marL="95250" marR="95250" marT="28575" marB="28575" anchor="ctr" horzOverflow="wrap">
+                  <a:tcPr marL="95250" marR="95250" marT="28575" marB="28575" anchor="ctr" horzOverflow="overflow">
                     <a:solidFill>
                       <a:srgbClr val="FFFFFF"/>
                     </a:solidFill>
@@ -10031,7 +11888,7 @@
                       </a:r>
                     </a:p>
                   </a:txBody>
-                  <a:tcPr marL="95250" marR="95250" marT="28575" marB="28575" anchor="ctr" horzOverflow="wrap">
+                  <a:tcPr marL="95250" marR="95250" marT="28575" marB="28575" anchor="ctr" horzOverflow="overflow">
                     <a:solidFill>
                       <a:srgbClr val="FFFFFF"/>
                     </a:solidFill>
@@ -10055,7 +11912,7 @@
                       </a:r>
                     </a:p>
                   </a:txBody>
-                  <a:tcPr marL="95250" marR="95250" marT="28575" marB="28575" anchor="ctr" horzOverflow="wrap">
+                  <a:tcPr marL="95250" marR="95250" marT="28575" marB="28575" anchor="ctr" horzOverflow="overflow">
                     <a:solidFill>
                       <a:srgbClr val="FFFFFF"/>
                     </a:solidFill>
@@ -10079,7 +11936,31 @@
                       </a:r>
                     </a:p>
                   </a:txBody>
-                  <a:tcPr marL="95250" marR="95250" marT="28575" marB="28575" anchor="ctr" horzOverflow="wrap">
+                  <a:tcPr marL="95250" marR="95250" marT="28575" marB="28575" anchor="ctr" horzOverflow="overflow">
+                    <a:solidFill>
+                      <a:srgbClr val="FFFFFF"/>
+                    </a:solidFill>
+                  </a:tcPr>
+                </a:tc>
+                <a:tc>
+                  <a:txBody>
+                    <a:bodyPr/>
+                    <a:lstStyle/>
+                    <a:p>
+                      <a:r>
+                        <a:rPr sz="1800">
+                          <a:solidFill>
+                            <a:srgbClr val="30515F"/>
+                          </a:solidFill>
+                          <a:latin typeface="Calibri"/>
+                          <a:ea typeface="Calibri"/>
+                          <a:cs typeface="Calibri"/>
+                        </a:rPr>
+                        <a:t/>
+                      </a:r>
+                    </a:p>
+                  </a:txBody>
+                  <a:tcPr marL="95250" marR="95250" marT="28575" marB="28575" anchor="ctr" horzOverflow="overflow">
                     <a:solidFill>
                       <a:srgbClr val="FFFFFF"/>
                     </a:solidFill>
@@ -10090,64 +11971,6 @@
           </a:graphicData>
         </a:graphic>
       </p:graphicFrame>
-      <p:sp>
-        <p:nvSpPr>
-          <p:cNvPr id="29" name="ctt:table_caption">
-            <a:extLst xmlns:a="http://schemas.openxmlformats.org/drawingml/2006/main">
-              <a:ext uri="{FF2B5EF4-FFF2-40B4-BE49-F238E27FC236}">
-                <a16:creationId xmlns:a16="http://schemas.microsoft.com/office/drawing/2014/main" id="{CC680E71-DBB8-4A43-840D-212DE658277C}"/>
-              </a:ext>
-            </a:extLst>
-          </p:cNvPr>
-          <p:cNvSpPr>
-            <a:spLocks xmlns:a="http://schemas.openxmlformats.org/drawingml/2006/main" noGrp="1"/>
-          </p:cNvSpPr>
-          <p:nvPr/>
-        </p:nvSpPr>
-        <p:spPr>
-          <a:xfrm xmlns:a="http://schemas.openxmlformats.org/drawingml/2006/main">
-            <a:off x="571500" y="6010275"/>
-            <a:ext cx="11001375" cy="276225"/>
-          </a:xfrm>
-          <a:prstGeom xmlns:a="http://schemas.openxmlformats.org/drawingml/2006/main" prst="rect">
-            <a:avLst/>
-          </a:prstGeom>
-          <a:noFill xmlns:a="http://schemas.openxmlformats.org/drawingml/2006/main"/>
-          <a:ln xmlns:a="http://schemas.openxmlformats.org/drawingml/2006/main" w="0">
-            <a:noFill/>
-          </a:ln>
-        </p:spPr>
-        <p:txBody>
-          <a:bodyPr xmlns:a="http://schemas.openxmlformats.org/drawingml/2006/main">
-            <a:noAutofit/>
-          </a:bodyPr>
-          <a:lstStyle xmlns:a="http://schemas.openxmlformats.org/drawingml/2006/main"/>
-          <a:p xmlns:a="http://schemas.openxmlformats.org/drawingml/2006/main">
-            <a:pPr>
-              <a:buNone/>
-              <a:defRPr sz="1350">
-                <a:solidFill>
-                  <a:srgbClr val="30515F"/>
-                </a:solidFill>
-                <a:latin typeface="Calibri"/>
-                <a:ea typeface="Calibri"/>
-                <a:cs typeface="Calibri"/>
-              </a:defRPr>
-            </a:pPr>
-            <a:r>
-              <a:rPr sz="1350">
-                <a:solidFill>
-                  <a:srgbClr val="30515F"/>
-                </a:solidFill>
-                <a:latin typeface="Calibri"/>
-                <a:ea typeface="Calibri"/>
-                <a:cs typeface="Calibri"/>
-              </a:rPr>
-              <a:t>{{table_caption}}</a:t>
-            </a:r>
-          </a:p>
-        </p:txBody>
-      </p:sp>
     </p:spTree>
     <p:extLst>
       <p:ext uri="{BB962C8B-B14F-4D97-AF65-F5344CB8AC3E}">
@@ -10179,7 +12002,7 @@
           <p:nvPr/>
         </p:nvPicPr>
         <p:blipFill>
-          <a:blip xmlns:r="http://schemas.openxmlformats.org/officeDocument/2006/relationships" xmlns:a="http://schemas.openxmlformats.org/drawingml/2006/main" r:embed="R91d0c864b4ee4941"/>
+          <a:blip xmlns:r="http://schemas.openxmlformats.org/officeDocument/2006/relationships" xmlns:a="http://schemas.openxmlformats.org/drawingml/2006/main" r:embed="Re87f1b8b6ff34d8a"/>
           <a:stretch xmlns:a="http://schemas.openxmlformats.org/drawingml/2006/main">
             <a:fillRect l="0" t="0" r="0" b="0"/>
           </a:stretch>
@@ -11208,7 +13031,7 @@
           <p:nvPr/>
         </p:nvPicPr>
         <p:blipFill>
-          <a:blip xmlns:r="http://schemas.openxmlformats.org/officeDocument/2006/relationships" xmlns:a="http://schemas.openxmlformats.org/drawingml/2006/main" r:embed="R4a94444b99c34ece"/>
+          <a:blip xmlns:r="http://schemas.openxmlformats.org/officeDocument/2006/relationships" xmlns:a="http://schemas.openxmlformats.org/drawingml/2006/main" r:embed="R8ae61110555b428a"/>
           <a:stretch xmlns:a="http://schemas.openxmlformats.org/drawingml/2006/main">
             <a:fillRect l="0" t="0" r="0" b="0"/>
           </a:stretch>
@@ -12237,7 +14060,7 @@
           <p:nvPr/>
         </p:nvPicPr>
         <p:blipFill>
-          <a:blip xmlns:r="http://schemas.openxmlformats.org/officeDocument/2006/relationships" xmlns:a="http://schemas.openxmlformats.org/drawingml/2006/main" r:embed="R8bb626cee18646ea"/>
+          <a:blip xmlns:r="http://schemas.openxmlformats.org/officeDocument/2006/relationships" xmlns:a="http://schemas.openxmlformats.org/drawingml/2006/main" r:embed="R35f69286d1ec459f"/>
           <a:stretch xmlns:a="http://schemas.openxmlformats.org/drawingml/2006/main">
             <a:fillRect l="0" t="0" r="0" b="0"/>
           </a:stretch>
@@ -13076,7 +14899,7 @@
           <p:nvPr/>
         </p:nvPicPr>
         <p:blipFill>
-          <a:blip xmlns:r="http://schemas.openxmlformats.org/officeDocument/2006/relationships" xmlns:a="http://schemas.openxmlformats.org/drawingml/2006/main" r:embed="R36d0faacb3a64252"/>
+          <a:blip xmlns:r="http://schemas.openxmlformats.org/officeDocument/2006/relationships" xmlns:a="http://schemas.openxmlformats.org/drawingml/2006/main" r:embed="R3fab7a75262647d0"/>
           <a:stretch xmlns:a="http://schemas.openxmlformats.org/drawingml/2006/main">
             <a:fillRect l="0" t="0" r="0" b="0"/>
           </a:stretch>

</xml_diff>